<commit_message>
Uploaded CS449 practice files, and updated CS 449 slides
</commit_message>
<xml_diff>
--- a/files/CS449/CS_0449_Recitation_2.pptx
+++ b/files/CS449/CS_0449_Recitation_2.pptx
@@ -6,36 +6,39 @@
   </p:sldMasterIdLst>
   <p:sldIdLst>
     <p:sldId id="256" r:id="rId2"/>
-    <p:sldId id="272" r:id="rId3"/>
-    <p:sldId id="257" r:id="rId4"/>
-    <p:sldId id="260" r:id="rId5"/>
-    <p:sldId id="259" r:id="rId6"/>
-    <p:sldId id="261" r:id="rId7"/>
-    <p:sldId id="264" r:id="rId8"/>
-    <p:sldId id="262" r:id="rId9"/>
-    <p:sldId id="265" r:id="rId10"/>
-    <p:sldId id="266" r:id="rId11"/>
-    <p:sldId id="258" r:id="rId12"/>
-    <p:sldId id="267" r:id="rId13"/>
-    <p:sldId id="268" r:id="rId14"/>
-    <p:sldId id="273" r:id="rId15"/>
-    <p:sldId id="276" r:id="rId16"/>
-    <p:sldId id="274" r:id="rId17"/>
-    <p:sldId id="277" r:id="rId18"/>
-    <p:sldId id="279" r:id="rId19"/>
-    <p:sldId id="278" r:id="rId20"/>
-    <p:sldId id="280" r:id="rId21"/>
-    <p:sldId id="281" r:id="rId22"/>
-    <p:sldId id="282" r:id="rId23"/>
-    <p:sldId id="283" r:id="rId24"/>
-    <p:sldId id="284" r:id="rId25"/>
-    <p:sldId id="287" r:id="rId26"/>
-    <p:sldId id="288" r:id="rId27"/>
-    <p:sldId id="285" r:id="rId28"/>
-    <p:sldId id="286" r:id="rId29"/>
-    <p:sldId id="269" r:id="rId30"/>
-    <p:sldId id="270" r:id="rId31"/>
-    <p:sldId id="271" r:id="rId32"/>
+    <p:sldId id="291" r:id="rId3"/>
+    <p:sldId id="272" r:id="rId4"/>
+    <p:sldId id="257" r:id="rId5"/>
+    <p:sldId id="260" r:id="rId6"/>
+    <p:sldId id="259" r:id="rId7"/>
+    <p:sldId id="261" r:id="rId8"/>
+    <p:sldId id="264" r:id="rId9"/>
+    <p:sldId id="262" r:id="rId10"/>
+    <p:sldId id="265" r:id="rId11"/>
+    <p:sldId id="266" r:id="rId12"/>
+    <p:sldId id="258" r:id="rId13"/>
+    <p:sldId id="267" r:id="rId14"/>
+    <p:sldId id="268" r:id="rId15"/>
+    <p:sldId id="273" r:id="rId16"/>
+    <p:sldId id="276" r:id="rId17"/>
+    <p:sldId id="274" r:id="rId18"/>
+    <p:sldId id="277" r:id="rId19"/>
+    <p:sldId id="279" r:id="rId20"/>
+    <p:sldId id="278" r:id="rId21"/>
+    <p:sldId id="280" r:id="rId22"/>
+    <p:sldId id="281" r:id="rId23"/>
+    <p:sldId id="282" r:id="rId24"/>
+    <p:sldId id="283" r:id="rId25"/>
+    <p:sldId id="284" r:id="rId26"/>
+    <p:sldId id="287" r:id="rId27"/>
+    <p:sldId id="288" r:id="rId28"/>
+    <p:sldId id="285" r:id="rId29"/>
+    <p:sldId id="286" r:id="rId30"/>
+    <p:sldId id="289" r:id="rId31"/>
+    <p:sldId id="290" r:id="rId32"/>
+    <p:sldId id="269" r:id="rId33"/>
+    <p:sldId id="270" r:id="rId34"/>
+    <p:sldId id="271" r:id="rId35"/>
   </p:sldIdLst>
   <p:sldSz cx="12192000" cy="6858000"/>
   <p:notesSz cx="6858000" cy="9144000"/>
@@ -6020,6 +6023,936 @@
 </file>
 
 <file path=ppt/slides/slide10.xml><?xml version="1.0" encoding="utf-8"?>
+<p:sld xmlns:a="http://schemas.openxmlformats.org/drawingml/2006/main" xmlns:r="http://schemas.openxmlformats.org/officeDocument/2006/relationships" xmlns:p="http://schemas.openxmlformats.org/presentationml/2006/main">
+  <p:cSld>
+    <p:spTree>
+      <p:nvGrpSpPr>
+        <p:cNvPr id="1" name=""/>
+        <p:cNvGrpSpPr/>
+        <p:nvPr/>
+      </p:nvGrpSpPr>
+      <p:grpSpPr>
+        <a:xfrm>
+          <a:off x="0" y="0"/>
+          <a:ext cx="0" cy="0"/>
+          <a:chOff x="0" y="0"/>
+          <a:chExt cx="0" cy="0"/>
+        </a:xfrm>
+      </p:grpSpPr>
+      <p:sp>
+        <p:nvSpPr>
+          <p:cNvPr id="2" name="Title 1">
+            <a:extLst>
+              <a:ext uri="{FF2B5EF4-FFF2-40B4-BE49-F238E27FC236}">
+                <a16:creationId xmlns:a16="http://schemas.microsoft.com/office/drawing/2014/main" id="{3CCD6262-0FD5-4436-9430-E0EB6B21C749}"/>
+              </a:ext>
+            </a:extLst>
+          </p:cNvPr>
+          <p:cNvSpPr>
+            <a:spLocks noGrp="1"/>
+          </p:cNvSpPr>
+          <p:nvPr>
+            <p:ph type="title"/>
+          </p:nvPr>
+        </p:nvSpPr>
+        <p:spPr/>
+        <p:txBody>
+          <a:bodyPr/>
+          <a:lstStyle/>
+          <a:p>
+            <a:r>
+              <a:rPr lang="en-US" dirty="0"/>
+              <a:t>Like a Locker Room!</a:t>
+            </a:r>
+          </a:p>
+        </p:txBody>
+      </p:sp>
+      <p:sp>
+        <p:nvSpPr>
+          <p:cNvPr id="3" name="Content Placeholder 2">
+            <a:extLst>
+              <a:ext uri="{FF2B5EF4-FFF2-40B4-BE49-F238E27FC236}">
+                <a16:creationId xmlns:a16="http://schemas.microsoft.com/office/drawing/2014/main" id="{8483FFE6-517E-4841-B36F-C053D682DDF1}"/>
+              </a:ext>
+            </a:extLst>
+          </p:cNvPr>
+          <p:cNvSpPr>
+            <a:spLocks noGrp="1"/>
+          </p:cNvSpPr>
+          <p:nvPr>
+            <p:ph idx="1"/>
+          </p:nvPr>
+        </p:nvSpPr>
+        <p:spPr/>
+        <p:txBody>
+          <a:bodyPr>
+            <a:normAutofit fontScale="55000" lnSpcReduction="20000"/>
+          </a:bodyPr>
+          <a:lstStyle/>
+          <a:p>
+            <a:pPr marL="0" indent="0">
+              <a:buNone/>
+            </a:pPr>
+            <a:r>
+              <a:rPr lang="en-US" dirty="0"/>
+              <a:t>1) Just like a locker </a:t>
+            </a:r>
+            <a:r>
+              <a:rPr lang="en-US" b="1" dirty="0"/>
+              <a:t>contains </a:t>
+            </a:r>
+            <a:r>
+              <a:rPr lang="en-US" b="1" i="1" dirty="0"/>
+              <a:t>things</a:t>
+            </a:r>
+            <a:r>
+              <a:rPr lang="en-US" dirty="0"/>
+              <a:t>…</a:t>
+            </a:r>
+          </a:p>
+          <a:p>
+            <a:pPr marL="0" indent="0">
+              <a:buNone/>
+            </a:pPr>
+            <a:r>
+              <a:rPr lang="en-US" dirty="0"/>
+              <a:t>- Variables contain </a:t>
+            </a:r>
+            <a:r>
+              <a:rPr lang="en-US" b="1" dirty="0"/>
+              <a:t>values</a:t>
+            </a:r>
+            <a:endParaRPr lang="en-US" dirty="0"/>
+          </a:p>
+          <a:p>
+            <a:pPr marL="0" indent="0">
+              <a:buNone/>
+            </a:pPr>
+            <a:r>
+              <a:rPr lang="en-US" dirty="0"/>
+              <a:t>- But a variable </a:t>
+            </a:r>
+            <a:r>
+              <a:rPr lang="en-US" i="1" dirty="0"/>
+              <a:t>is a </a:t>
+            </a:r>
+            <a:r>
+              <a:rPr lang="en-US" b="1" i="1" dirty="0"/>
+              <a:t>thing itself</a:t>
+            </a:r>
+            <a:endParaRPr lang="en-US" dirty="0"/>
+          </a:p>
+          <a:p>
+            <a:pPr marL="0" indent="0">
+              <a:buNone/>
+            </a:pPr>
+            <a:r>
+              <a:rPr lang="en-US" dirty="0"/>
+              <a:t>2) Each variable is like a locker:</a:t>
+            </a:r>
+          </a:p>
+          <a:p>
+            <a:pPr marL="0" indent="0">
+              <a:buNone/>
+            </a:pPr>
+            <a:r>
+              <a:rPr lang="en-US" dirty="0"/>
+              <a:t>- It has a </a:t>
+            </a:r>
+            <a:r>
+              <a:rPr lang="en-US" b="1" dirty="0"/>
+              <a:t>number: </a:t>
+            </a:r>
+            <a:r>
+              <a:rPr lang="en-US" dirty="0"/>
+              <a:t>its </a:t>
+            </a:r>
+            <a:r>
+              <a:rPr lang="en-US" b="1" dirty="0"/>
+              <a:t>address</a:t>
+            </a:r>
+            <a:endParaRPr lang="en-US" dirty="0"/>
+          </a:p>
+          <a:p>
+            <a:pPr marL="0" indent="0">
+              <a:buNone/>
+            </a:pPr>
+            <a:r>
+              <a:rPr lang="en-US" dirty="0"/>
+              <a:t>- It </a:t>
+            </a:r>
+            <a:r>
+              <a:rPr lang="en-US" b="1" dirty="0"/>
+              <a:t>contains </a:t>
+            </a:r>
+            <a:r>
+              <a:rPr lang="en-US" dirty="0"/>
+              <a:t>something: its </a:t>
+            </a:r>
+            <a:r>
+              <a:rPr lang="en-US" b="1" dirty="0"/>
+              <a:t>value</a:t>
+            </a:r>
+            <a:endParaRPr lang="en-US" dirty="0"/>
+          </a:p>
+          <a:p>
+            <a:pPr marL="0" indent="0">
+              <a:buNone/>
+            </a:pPr>
+            <a:r>
+              <a:rPr lang="en-US" dirty="0"/>
+              <a:t>- It </a:t>
+            </a:r>
+            <a:r>
+              <a:rPr lang="en-US" b="1" dirty="0"/>
+              <a:t>belongs</a:t>
+            </a:r>
+            <a:r>
+              <a:rPr lang="en-US" dirty="0"/>
+              <a:t> to someone: its </a:t>
+            </a:r>
+            <a:r>
+              <a:rPr lang="en-US" b="1" dirty="0"/>
+              <a:t>owner</a:t>
+            </a:r>
+            <a:endParaRPr lang="en-US" dirty="0"/>
+          </a:p>
+          <a:p>
+            <a:pPr marL="0" indent="0">
+              <a:buNone/>
+            </a:pPr>
+            <a:r>
+              <a:rPr lang="en-US" dirty="0"/>
+              <a:t>3) How do you </a:t>
+            </a:r>
+            <a:r>
+              <a:rPr lang="en-US" i="1" dirty="0"/>
+              <a:t>give </a:t>
+            </a:r>
+            <a:r>
+              <a:rPr lang="en-US" b="1" i="1" dirty="0"/>
+              <a:t>someone else access</a:t>
+            </a:r>
+            <a:r>
+              <a:rPr lang="en-US" i="1" dirty="0"/>
+              <a:t> </a:t>
+            </a:r>
+            <a:r>
+              <a:rPr lang="en-US" dirty="0"/>
+              <a:t>to your variable?</a:t>
+            </a:r>
+          </a:p>
+          <a:p>
+            <a:pPr marL="0" indent="0">
+              <a:buNone/>
+            </a:pPr>
+            <a:r>
+              <a:rPr lang="en-US" dirty="0"/>
+              <a:t>- </a:t>
+            </a:r>
+            <a:r>
+              <a:rPr lang="en-US" b="1" i="1" dirty="0"/>
+              <a:t>You give them the locker number</a:t>
+            </a:r>
+            <a:r>
+              <a:rPr lang="en-US" i="1" dirty="0"/>
+              <a:t>.</a:t>
+            </a:r>
+            <a:endParaRPr lang="en-US" dirty="0"/>
+          </a:p>
+          <a:p>
+            <a:pPr marL="0" lvl="0" indent="0">
+              <a:buNone/>
+            </a:pPr>
+            <a:r>
+              <a:rPr lang="en-US" dirty="0"/>
+              <a:t>- Which is its </a:t>
+            </a:r>
+            <a:r>
+              <a:rPr lang="en-US" b="1" dirty="0"/>
+              <a:t>memory address.</a:t>
+            </a:r>
+            <a:endParaRPr lang="en-US" dirty="0"/>
+          </a:p>
+          <a:p>
+            <a:pPr marL="0" indent="0">
+              <a:buNone/>
+            </a:pPr>
+            <a:r>
+              <a:rPr lang="en-US" dirty="0"/>
+              <a:t>- Variable names are just a convenient way to refer to their addresses!</a:t>
+            </a:r>
+          </a:p>
+          <a:p>
+            <a:endParaRPr lang="en-US" dirty="0"/>
+          </a:p>
+        </p:txBody>
+      </p:sp>
+      <p:pic>
+        <p:nvPicPr>
+          <p:cNvPr id="4" name="Picture 3">
+            <a:extLst>
+              <a:ext uri="{FF2B5EF4-FFF2-40B4-BE49-F238E27FC236}">
+                <a16:creationId xmlns:a16="http://schemas.microsoft.com/office/drawing/2014/main" id="{005528FB-2413-41DC-91E4-F58E9FCA38D8}"/>
+              </a:ext>
+            </a:extLst>
+          </p:cNvPr>
+          <p:cNvPicPr/>
+          <p:nvPr/>
+        </p:nvPicPr>
+        <p:blipFill>
+          <a:blip r:embed="rId2">
+            <a:extLst>
+              <a:ext uri="{28A0092B-C50C-407E-A947-70E740481C1C}">
+                <a14:useLocalDpi xmlns:a14="http://schemas.microsoft.com/office/drawing/2010/main" val="0"/>
+              </a:ext>
+            </a:extLst>
+          </a:blip>
+          <a:stretch>
+            <a:fillRect/>
+          </a:stretch>
+        </p:blipFill>
+        <p:spPr>
+          <a:xfrm>
+            <a:off x="5869952" y="2556932"/>
+            <a:ext cx="4893762" cy="3021504"/>
+          </a:xfrm>
+          <a:prstGeom prst="rect">
+            <a:avLst/>
+          </a:prstGeom>
+        </p:spPr>
+      </p:pic>
+    </p:spTree>
+    <p:extLst>
+      <p:ext uri="{BB962C8B-B14F-4D97-AF65-F5344CB8AC3E}">
+        <p14:creationId xmlns:p14="http://schemas.microsoft.com/office/powerpoint/2010/main" val="1700655484"/>
+      </p:ext>
+    </p:extLst>
+  </p:cSld>
+  <p:clrMapOvr>
+    <a:masterClrMapping/>
+  </p:clrMapOvr>
+  <p:timing>
+    <p:tnLst>
+      <p:par>
+        <p:cTn id="1" dur="indefinite" restart="never" nodeType="tmRoot">
+          <p:childTnLst>
+            <p:seq concurrent="1" nextAc="seek">
+              <p:cTn id="2" dur="indefinite" nodeType="mainSeq">
+                <p:childTnLst>
+                  <p:par>
+                    <p:cTn id="3" fill="hold">
+                      <p:stCondLst>
+                        <p:cond delay="indefinite"/>
+                      </p:stCondLst>
+                      <p:childTnLst>
+                        <p:par>
+                          <p:cTn id="4" fill="hold">
+                            <p:stCondLst>
+                              <p:cond delay="0"/>
+                            </p:stCondLst>
+                            <p:childTnLst>
+                              <p:par>
+                                <p:cTn id="5" presetID="1" presetClass="entr" presetSubtype="0" fill="hold" grpId="0" nodeType="clickEffect">
+                                  <p:stCondLst>
+                                    <p:cond delay="0"/>
+                                  </p:stCondLst>
+                                  <p:childTnLst>
+                                    <p:set>
+                                      <p:cBhvr>
+                                        <p:cTn id="6" dur="1" fill="hold">
+                                          <p:stCondLst>
+                                            <p:cond delay="0"/>
+                                          </p:stCondLst>
+                                        </p:cTn>
+                                        <p:tgtEl>
+                                          <p:spTgt spid="3">
+                                            <p:txEl>
+                                              <p:pRg st="0" end="0"/>
+                                            </p:txEl>
+                                          </p:spTgt>
+                                        </p:tgtEl>
+                                        <p:attrNameLst>
+                                          <p:attrName>style.visibility</p:attrName>
+                                        </p:attrNameLst>
+                                      </p:cBhvr>
+                                      <p:to>
+                                        <p:strVal val="visible"/>
+                                      </p:to>
+                                    </p:set>
+                                  </p:childTnLst>
+                                </p:cTn>
+                              </p:par>
+                            </p:childTnLst>
+                          </p:cTn>
+                        </p:par>
+                      </p:childTnLst>
+                    </p:cTn>
+                  </p:par>
+                  <p:par>
+                    <p:cTn id="7" fill="hold">
+                      <p:stCondLst>
+                        <p:cond delay="indefinite"/>
+                      </p:stCondLst>
+                      <p:childTnLst>
+                        <p:par>
+                          <p:cTn id="8" fill="hold">
+                            <p:stCondLst>
+                              <p:cond delay="0"/>
+                            </p:stCondLst>
+                            <p:childTnLst>
+                              <p:par>
+                                <p:cTn id="9" presetID="1" presetClass="entr" presetSubtype="0" fill="hold" grpId="0" nodeType="clickEffect">
+                                  <p:stCondLst>
+                                    <p:cond delay="0"/>
+                                  </p:stCondLst>
+                                  <p:childTnLst>
+                                    <p:set>
+                                      <p:cBhvr>
+                                        <p:cTn id="10" dur="1" fill="hold">
+                                          <p:stCondLst>
+                                            <p:cond delay="0"/>
+                                          </p:stCondLst>
+                                        </p:cTn>
+                                        <p:tgtEl>
+                                          <p:spTgt spid="3">
+                                            <p:txEl>
+                                              <p:pRg st="1" end="1"/>
+                                            </p:txEl>
+                                          </p:spTgt>
+                                        </p:tgtEl>
+                                        <p:attrNameLst>
+                                          <p:attrName>style.visibility</p:attrName>
+                                        </p:attrNameLst>
+                                      </p:cBhvr>
+                                      <p:to>
+                                        <p:strVal val="visible"/>
+                                      </p:to>
+                                    </p:set>
+                                  </p:childTnLst>
+                                </p:cTn>
+                              </p:par>
+                            </p:childTnLst>
+                          </p:cTn>
+                        </p:par>
+                      </p:childTnLst>
+                    </p:cTn>
+                  </p:par>
+                  <p:par>
+                    <p:cTn id="11" fill="hold">
+                      <p:stCondLst>
+                        <p:cond delay="indefinite"/>
+                      </p:stCondLst>
+                      <p:childTnLst>
+                        <p:par>
+                          <p:cTn id="12" fill="hold">
+                            <p:stCondLst>
+                              <p:cond delay="0"/>
+                            </p:stCondLst>
+                            <p:childTnLst>
+                              <p:par>
+                                <p:cTn id="13" presetID="1" presetClass="entr" presetSubtype="0" fill="hold" grpId="0" nodeType="clickEffect">
+                                  <p:stCondLst>
+                                    <p:cond delay="0"/>
+                                  </p:stCondLst>
+                                  <p:childTnLst>
+                                    <p:set>
+                                      <p:cBhvr>
+                                        <p:cTn id="14" dur="1" fill="hold">
+                                          <p:stCondLst>
+                                            <p:cond delay="0"/>
+                                          </p:stCondLst>
+                                        </p:cTn>
+                                        <p:tgtEl>
+                                          <p:spTgt spid="3">
+                                            <p:txEl>
+                                              <p:pRg st="2" end="2"/>
+                                            </p:txEl>
+                                          </p:spTgt>
+                                        </p:tgtEl>
+                                        <p:attrNameLst>
+                                          <p:attrName>style.visibility</p:attrName>
+                                        </p:attrNameLst>
+                                      </p:cBhvr>
+                                      <p:to>
+                                        <p:strVal val="visible"/>
+                                      </p:to>
+                                    </p:set>
+                                  </p:childTnLst>
+                                </p:cTn>
+                              </p:par>
+                            </p:childTnLst>
+                          </p:cTn>
+                        </p:par>
+                      </p:childTnLst>
+                    </p:cTn>
+                  </p:par>
+                  <p:par>
+                    <p:cTn id="15" fill="hold">
+                      <p:stCondLst>
+                        <p:cond delay="indefinite"/>
+                      </p:stCondLst>
+                      <p:childTnLst>
+                        <p:par>
+                          <p:cTn id="16" fill="hold">
+                            <p:stCondLst>
+                              <p:cond delay="0"/>
+                            </p:stCondLst>
+                            <p:childTnLst>
+                              <p:par>
+                                <p:cTn id="17" presetID="1" presetClass="entr" presetSubtype="0" fill="hold" grpId="0" nodeType="clickEffect">
+                                  <p:stCondLst>
+                                    <p:cond delay="0"/>
+                                  </p:stCondLst>
+                                  <p:childTnLst>
+                                    <p:set>
+                                      <p:cBhvr>
+                                        <p:cTn id="18" dur="1" fill="hold">
+                                          <p:stCondLst>
+                                            <p:cond delay="0"/>
+                                          </p:stCondLst>
+                                        </p:cTn>
+                                        <p:tgtEl>
+                                          <p:spTgt spid="3">
+                                            <p:txEl>
+                                              <p:pRg st="3" end="3"/>
+                                            </p:txEl>
+                                          </p:spTgt>
+                                        </p:tgtEl>
+                                        <p:attrNameLst>
+                                          <p:attrName>style.visibility</p:attrName>
+                                        </p:attrNameLst>
+                                      </p:cBhvr>
+                                      <p:to>
+                                        <p:strVal val="visible"/>
+                                      </p:to>
+                                    </p:set>
+                                  </p:childTnLst>
+                                </p:cTn>
+                              </p:par>
+                            </p:childTnLst>
+                          </p:cTn>
+                        </p:par>
+                      </p:childTnLst>
+                    </p:cTn>
+                  </p:par>
+                  <p:par>
+                    <p:cTn id="19" fill="hold">
+                      <p:stCondLst>
+                        <p:cond delay="indefinite"/>
+                      </p:stCondLst>
+                      <p:childTnLst>
+                        <p:par>
+                          <p:cTn id="20" fill="hold">
+                            <p:stCondLst>
+                              <p:cond delay="0"/>
+                            </p:stCondLst>
+                            <p:childTnLst>
+                              <p:par>
+                                <p:cTn id="21" presetID="1" presetClass="entr" presetSubtype="0" fill="hold" grpId="0" nodeType="clickEffect">
+                                  <p:stCondLst>
+                                    <p:cond delay="0"/>
+                                  </p:stCondLst>
+                                  <p:childTnLst>
+                                    <p:set>
+                                      <p:cBhvr>
+                                        <p:cTn id="22" dur="1" fill="hold">
+                                          <p:stCondLst>
+                                            <p:cond delay="0"/>
+                                          </p:stCondLst>
+                                        </p:cTn>
+                                        <p:tgtEl>
+                                          <p:spTgt spid="3">
+                                            <p:txEl>
+                                              <p:pRg st="4" end="4"/>
+                                            </p:txEl>
+                                          </p:spTgt>
+                                        </p:tgtEl>
+                                        <p:attrNameLst>
+                                          <p:attrName>style.visibility</p:attrName>
+                                        </p:attrNameLst>
+                                      </p:cBhvr>
+                                      <p:to>
+                                        <p:strVal val="visible"/>
+                                      </p:to>
+                                    </p:set>
+                                  </p:childTnLst>
+                                </p:cTn>
+                              </p:par>
+                            </p:childTnLst>
+                          </p:cTn>
+                        </p:par>
+                      </p:childTnLst>
+                    </p:cTn>
+                  </p:par>
+                  <p:par>
+                    <p:cTn id="23" fill="hold">
+                      <p:stCondLst>
+                        <p:cond delay="indefinite"/>
+                      </p:stCondLst>
+                      <p:childTnLst>
+                        <p:par>
+                          <p:cTn id="24" fill="hold">
+                            <p:stCondLst>
+                              <p:cond delay="0"/>
+                            </p:stCondLst>
+                            <p:childTnLst>
+                              <p:par>
+                                <p:cTn id="25" presetID="1" presetClass="entr" presetSubtype="0" fill="hold" grpId="0" nodeType="clickEffect">
+                                  <p:stCondLst>
+                                    <p:cond delay="0"/>
+                                  </p:stCondLst>
+                                  <p:childTnLst>
+                                    <p:set>
+                                      <p:cBhvr>
+                                        <p:cTn id="26" dur="1" fill="hold">
+                                          <p:stCondLst>
+                                            <p:cond delay="0"/>
+                                          </p:stCondLst>
+                                        </p:cTn>
+                                        <p:tgtEl>
+                                          <p:spTgt spid="3">
+                                            <p:txEl>
+                                              <p:pRg st="5" end="5"/>
+                                            </p:txEl>
+                                          </p:spTgt>
+                                        </p:tgtEl>
+                                        <p:attrNameLst>
+                                          <p:attrName>style.visibility</p:attrName>
+                                        </p:attrNameLst>
+                                      </p:cBhvr>
+                                      <p:to>
+                                        <p:strVal val="visible"/>
+                                      </p:to>
+                                    </p:set>
+                                  </p:childTnLst>
+                                </p:cTn>
+                              </p:par>
+                            </p:childTnLst>
+                          </p:cTn>
+                        </p:par>
+                      </p:childTnLst>
+                    </p:cTn>
+                  </p:par>
+                  <p:par>
+                    <p:cTn id="27" fill="hold">
+                      <p:stCondLst>
+                        <p:cond delay="indefinite"/>
+                      </p:stCondLst>
+                      <p:childTnLst>
+                        <p:par>
+                          <p:cTn id="28" fill="hold">
+                            <p:stCondLst>
+                              <p:cond delay="0"/>
+                            </p:stCondLst>
+                            <p:childTnLst>
+                              <p:par>
+                                <p:cTn id="29" presetID="1" presetClass="entr" presetSubtype="0" fill="hold" grpId="0" nodeType="clickEffect">
+                                  <p:stCondLst>
+                                    <p:cond delay="0"/>
+                                  </p:stCondLst>
+                                  <p:childTnLst>
+                                    <p:set>
+                                      <p:cBhvr>
+                                        <p:cTn id="30" dur="1" fill="hold">
+                                          <p:stCondLst>
+                                            <p:cond delay="0"/>
+                                          </p:stCondLst>
+                                        </p:cTn>
+                                        <p:tgtEl>
+                                          <p:spTgt spid="3">
+                                            <p:txEl>
+                                              <p:pRg st="6" end="6"/>
+                                            </p:txEl>
+                                          </p:spTgt>
+                                        </p:tgtEl>
+                                        <p:attrNameLst>
+                                          <p:attrName>style.visibility</p:attrName>
+                                        </p:attrNameLst>
+                                      </p:cBhvr>
+                                      <p:to>
+                                        <p:strVal val="visible"/>
+                                      </p:to>
+                                    </p:set>
+                                  </p:childTnLst>
+                                </p:cTn>
+                              </p:par>
+                            </p:childTnLst>
+                          </p:cTn>
+                        </p:par>
+                      </p:childTnLst>
+                    </p:cTn>
+                  </p:par>
+                  <p:par>
+                    <p:cTn id="31" fill="hold">
+                      <p:stCondLst>
+                        <p:cond delay="indefinite"/>
+                      </p:stCondLst>
+                      <p:childTnLst>
+                        <p:par>
+                          <p:cTn id="32" fill="hold">
+                            <p:stCondLst>
+                              <p:cond delay="0"/>
+                            </p:stCondLst>
+                            <p:childTnLst>
+                              <p:par>
+                                <p:cTn id="33" presetID="1" presetClass="entr" presetSubtype="0" fill="hold" grpId="0" nodeType="clickEffect">
+                                  <p:stCondLst>
+                                    <p:cond delay="0"/>
+                                  </p:stCondLst>
+                                  <p:childTnLst>
+                                    <p:set>
+                                      <p:cBhvr>
+                                        <p:cTn id="34" dur="1" fill="hold">
+                                          <p:stCondLst>
+                                            <p:cond delay="0"/>
+                                          </p:stCondLst>
+                                        </p:cTn>
+                                        <p:tgtEl>
+                                          <p:spTgt spid="3">
+                                            <p:txEl>
+                                              <p:pRg st="7" end="7"/>
+                                            </p:txEl>
+                                          </p:spTgt>
+                                        </p:tgtEl>
+                                        <p:attrNameLst>
+                                          <p:attrName>style.visibility</p:attrName>
+                                        </p:attrNameLst>
+                                      </p:cBhvr>
+                                      <p:to>
+                                        <p:strVal val="visible"/>
+                                      </p:to>
+                                    </p:set>
+                                  </p:childTnLst>
+                                </p:cTn>
+                              </p:par>
+                            </p:childTnLst>
+                          </p:cTn>
+                        </p:par>
+                      </p:childTnLst>
+                    </p:cTn>
+                  </p:par>
+                  <p:par>
+                    <p:cTn id="35" fill="hold">
+                      <p:stCondLst>
+                        <p:cond delay="indefinite"/>
+                      </p:stCondLst>
+                      <p:childTnLst>
+                        <p:par>
+                          <p:cTn id="36" fill="hold">
+                            <p:stCondLst>
+                              <p:cond delay="0"/>
+                            </p:stCondLst>
+                            <p:childTnLst>
+                              <p:par>
+                                <p:cTn id="37" presetID="1" presetClass="entr" presetSubtype="0" fill="hold" grpId="0" nodeType="clickEffect">
+                                  <p:stCondLst>
+                                    <p:cond delay="0"/>
+                                  </p:stCondLst>
+                                  <p:childTnLst>
+                                    <p:set>
+                                      <p:cBhvr>
+                                        <p:cTn id="38" dur="1" fill="hold">
+                                          <p:stCondLst>
+                                            <p:cond delay="0"/>
+                                          </p:stCondLst>
+                                        </p:cTn>
+                                        <p:tgtEl>
+                                          <p:spTgt spid="3">
+                                            <p:txEl>
+                                              <p:pRg st="8" end="8"/>
+                                            </p:txEl>
+                                          </p:spTgt>
+                                        </p:tgtEl>
+                                        <p:attrNameLst>
+                                          <p:attrName>style.visibility</p:attrName>
+                                        </p:attrNameLst>
+                                      </p:cBhvr>
+                                      <p:to>
+                                        <p:strVal val="visible"/>
+                                      </p:to>
+                                    </p:set>
+                                  </p:childTnLst>
+                                </p:cTn>
+                              </p:par>
+                            </p:childTnLst>
+                          </p:cTn>
+                        </p:par>
+                      </p:childTnLst>
+                    </p:cTn>
+                  </p:par>
+                  <p:par>
+                    <p:cTn id="39" fill="hold">
+                      <p:stCondLst>
+                        <p:cond delay="indefinite"/>
+                      </p:stCondLst>
+                      <p:childTnLst>
+                        <p:par>
+                          <p:cTn id="40" fill="hold">
+                            <p:stCondLst>
+                              <p:cond delay="0"/>
+                            </p:stCondLst>
+                            <p:childTnLst>
+                              <p:par>
+                                <p:cTn id="41" presetID="1" presetClass="entr" presetSubtype="0" fill="hold" grpId="0" nodeType="clickEffect">
+                                  <p:stCondLst>
+                                    <p:cond delay="0"/>
+                                  </p:stCondLst>
+                                  <p:childTnLst>
+                                    <p:set>
+                                      <p:cBhvr>
+                                        <p:cTn id="42" dur="1" fill="hold">
+                                          <p:stCondLst>
+                                            <p:cond delay="0"/>
+                                          </p:stCondLst>
+                                        </p:cTn>
+                                        <p:tgtEl>
+                                          <p:spTgt spid="3">
+                                            <p:txEl>
+                                              <p:pRg st="9" end="9"/>
+                                            </p:txEl>
+                                          </p:spTgt>
+                                        </p:tgtEl>
+                                        <p:attrNameLst>
+                                          <p:attrName>style.visibility</p:attrName>
+                                        </p:attrNameLst>
+                                      </p:cBhvr>
+                                      <p:to>
+                                        <p:strVal val="visible"/>
+                                      </p:to>
+                                    </p:set>
+                                  </p:childTnLst>
+                                </p:cTn>
+                              </p:par>
+                            </p:childTnLst>
+                          </p:cTn>
+                        </p:par>
+                      </p:childTnLst>
+                    </p:cTn>
+                  </p:par>
+                  <p:par>
+                    <p:cTn id="43" fill="hold">
+                      <p:stCondLst>
+                        <p:cond delay="indefinite"/>
+                      </p:stCondLst>
+                      <p:childTnLst>
+                        <p:par>
+                          <p:cTn id="44" fill="hold">
+                            <p:stCondLst>
+                              <p:cond delay="0"/>
+                            </p:stCondLst>
+                            <p:childTnLst>
+                              <p:par>
+                                <p:cTn id="45" presetID="1" presetClass="entr" presetSubtype="0" fill="hold" grpId="0" nodeType="clickEffect">
+                                  <p:stCondLst>
+                                    <p:cond delay="0"/>
+                                  </p:stCondLst>
+                                  <p:childTnLst>
+                                    <p:set>
+                                      <p:cBhvr>
+                                        <p:cTn id="46" dur="1" fill="hold">
+                                          <p:stCondLst>
+                                            <p:cond delay="0"/>
+                                          </p:stCondLst>
+                                        </p:cTn>
+                                        <p:tgtEl>
+                                          <p:spTgt spid="3">
+                                            <p:txEl>
+                                              <p:pRg st="10" end="10"/>
+                                            </p:txEl>
+                                          </p:spTgt>
+                                        </p:tgtEl>
+                                        <p:attrNameLst>
+                                          <p:attrName>style.visibility</p:attrName>
+                                        </p:attrNameLst>
+                                      </p:cBhvr>
+                                      <p:to>
+                                        <p:strVal val="visible"/>
+                                      </p:to>
+                                    </p:set>
+                                  </p:childTnLst>
+                                </p:cTn>
+                              </p:par>
+                            </p:childTnLst>
+                          </p:cTn>
+                        </p:par>
+                      </p:childTnLst>
+                    </p:cTn>
+                  </p:par>
+                  <p:par>
+                    <p:cTn id="47" fill="hold">
+                      <p:stCondLst>
+                        <p:cond delay="indefinite"/>
+                      </p:stCondLst>
+                      <p:childTnLst>
+                        <p:par>
+                          <p:cTn id="48" fill="hold">
+                            <p:stCondLst>
+                              <p:cond delay="0"/>
+                            </p:stCondLst>
+                            <p:childTnLst>
+                              <p:par>
+                                <p:cTn id="49" presetID="1" presetClass="entr" presetSubtype="0" fill="hold" nodeType="clickEffect">
+                                  <p:stCondLst>
+                                    <p:cond delay="0"/>
+                                  </p:stCondLst>
+                                  <p:childTnLst>
+                                    <p:set>
+                                      <p:cBhvr>
+                                        <p:cTn id="50" dur="1" fill="hold">
+                                          <p:stCondLst>
+                                            <p:cond delay="0"/>
+                                          </p:stCondLst>
+                                        </p:cTn>
+                                        <p:tgtEl>
+                                          <p:spTgt spid="4"/>
+                                        </p:tgtEl>
+                                        <p:attrNameLst>
+                                          <p:attrName>style.visibility</p:attrName>
+                                        </p:attrNameLst>
+                                      </p:cBhvr>
+                                      <p:to>
+                                        <p:strVal val="visible"/>
+                                      </p:to>
+                                    </p:set>
+                                  </p:childTnLst>
+                                </p:cTn>
+                              </p:par>
+                            </p:childTnLst>
+                          </p:cTn>
+                        </p:par>
+                      </p:childTnLst>
+                    </p:cTn>
+                  </p:par>
+                </p:childTnLst>
+              </p:cTn>
+              <p:prevCondLst>
+                <p:cond evt="onPrev" delay="0">
+                  <p:tgtEl>
+                    <p:sldTgt/>
+                  </p:tgtEl>
+                </p:cond>
+              </p:prevCondLst>
+              <p:nextCondLst>
+                <p:cond evt="onNext" delay="0">
+                  <p:tgtEl>
+                    <p:sldTgt/>
+                  </p:tgtEl>
+                </p:cond>
+              </p:nextCondLst>
+            </p:seq>
+          </p:childTnLst>
+        </p:cTn>
+      </p:par>
+    </p:tnLst>
+    <p:bldLst>
+      <p:bldP spid="3" grpId="0" build="p"/>
+    </p:bldLst>
+  </p:timing>
+</p:sld>
+</file>
+
+<file path=ppt/slides/slide11.xml><?xml version="1.0" encoding="utf-8"?>
 <p:sld xmlns:a="http://schemas.openxmlformats.org/drawingml/2006/main" xmlns:r="http://schemas.openxmlformats.org/officeDocument/2006/relationships" xmlns:p="http://schemas.openxmlformats.org/presentationml/2006/main">
   <p:cSld>
     <p:spTree>
@@ -6756,7 +7689,7 @@
 </p:sld>
 </file>
 
-<file path=ppt/slides/slide11.xml><?xml version="1.0" encoding="utf-8"?>
+<file path=ppt/slides/slide12.xml><?xml version="1.0" encoding="utf-8"?>
 <p:sld xmlns:a="http://schemas.openxmlformats.org/drawingml/2006/main" xmlns:r="http://schemas.openxmlformats.org/officeDocument/2006/relationships" xmlns:p="http://schemas.openxmlformats.org/presentationml/2006/main">
   <p:cSld>
     <p:spTree>
@@ -6895,7 +7828,7 @@
 </p:sld>
 </file>
 
-<file path=ppt/slides/slide12.xml><?xml version="1.0" encoding="utf-8"?>
+<file path=ppt/slides/slide13.xml><?xml version="1.0" encoding="utf-8"?>
 <p:sld xmlns:a="http://schemas.openxmlformats.org/drawingml/2006/main" xmlns:r="http://schemas.openxmlformats.org/officeDocument/2006/relationships" xmlns:p="http://schemas.openxmlformats.org/presentationml/2006/main">
   <p:cSld>
     <p:spTree>
@@ -7190,7 +8123,7 @@
 </p:sld>
 </file>
 
-<file path=ppt/slides/slide13.xml><?xml version="1.0" encoding="utf-8"?>
+<file path=ppt/slides/slide14.xml><?xml version="1.0" encoding="utf-8"?>
 <p:sld xmlns:a="http://schemas.openxmlformats.org/drawingml/2006/main" xmlns:r="http://schemas.openxmlformats.org/officeDocument/2006/relationships" xmlns:p="http://schemas.openxmlformats.org/presentationml/2006/main">
   <p:cSld>
     <p:spTree>
@@ -7562,7 +8495,7 @@
 </p:sld>
 </file>
 
-<file path=ppt/slides/slide14.xml><?xml version="1.0" encoding="utf-8"?>
+<file path=ppt/slides/slide15.xml><?xml version="1.0" encoding="utf-8"?>
 <p:sld xmlns:a="http://schemas.openxmlformats.org/drawingml/2006/main" xmlns:r="http://schemas.openxmlformats.org/officeDocument/2006/relationships" xmlns:p="http://schemas.openxmlformats.org/presentationml/2006/main">
   <p:cSld>
     <p:spTree>
@@ -7934,7 +8867,7 @@
 </p:sld>
 </file>
 
-<file path=ppt/slides/slide15.xml><?xml version="1.0" encoding="utf-8"?>
+<file path=ppt/slides/slide16.xml><?xml version="1.0" encoding="utf-8"?>
 <p:sld xmlns:a="http://schemas.openxmlformats.org/drawingml/2006/main" xmlns:r="http://schemas.openxmlformats.org/officeDocument/2006/relationships" xmlns:p="http://schemas.openxmlformats.org/presentationml/2006/main">
   <p:cSld>
     <p:spTree>
@@ -8306,7 +9239,7 @@
 </p:sld>
 </file>
 
-<file path=ppt/slides/slide16.xml><?xml version="1.0" encoding="utf-8"?>
+<file path=ppt/slides/slide17.xml><?xml version="1.0" encoding="utf-8"?>
 <p:sld xmlns:a="http://schemas.openxmlformats.org/drawingml/2006/main" xmlns:r="http://schemas.openxmlformats.org/officeDocument/2006/relationships" xmlns:p="http://schemas.openxmlformats.org/presentationml/2006/main">
   <p:cSld>
     <p:spTree>
@@ -8703,7 +9636,7 @@
 </p:sld>
 </file>
 
-<file path=ppt/slides/slide17.xml><?xml version="1.0" encoding="utf-8"?>
+<file path=ppt/slides/slide18.xml><?xml version="1.0" encoding="utf-8"?>
 <p:sld xmlns:a="http://schemas.openxmlformats.org/drawingml/2006/main" xmlns:r="http://schemas.openxmlformats.org/officeDocument/2006/relationships" xmlns:p="http://schemas.openxmlformats.org/presentationml/2006/main">
   <p:cSld>
     <p:spTree>
@@ -8776,7 +9709,7 @@
           <a:p>
             <a:r>
               <a:rPr lang="en-US" dirty="0"/>
-              <a:t>But, now if we do:</a:t>
+              <a:t>But now if we do:</a:t>
             </a:r>
           </a:p>
           <a:p>
@@ -9031,7 +9964,7 @@
 </p:sld>
 </file>
 
-<file path=ppt/slides/slide18.xml><?xml version="1.0" encoding="utf-8"?>
+<file path=ppt/slides/slide19.xml><?xml version="1.0" encoding="utf-8"?>
 <p:sld xmlns:a="http://schemas.openxmlformats.org/drawingml/2006/main" xmlns:r="http://schemas.openxmlformats.org/officeDocument/2006/relationships" xmlns:p="http://schemas.openxmlformats.org/presentationml/2006/main">
   <p:cSld>
     <p:bg>
@@ -9334,7 +10267,137 @@
 </p:sld>
 </file>
 
-<file path=ppt/slides/slide19.xml><?xml version="1.0" encoding="utf-8"?>
+<file path=ppt/slides/slide2.xml><?xml version="1.0" encoding="utf-8"?>
+<p:sld xmlns:a="http://schemas.openxmlformats.org/drawingml/2006/main" xmlns:r="http://schemas.openxmlformats.org/officeDocument/2006/relationships" xmlns:p="http://schemas.openxmlformats.org/presentationml/2006/main">
+  <p:cSld>
+    <p:spTree>
+      <p:nvGrpSpPr>
+        <p:cNvPr id="1" name=""/>
+        <p:cNvGrpSpPr/>
+        <p:nvPr/>
+      </p:nvGrpSpPr>
+      <p:grpSpPr>
+        <a:xfrm>
+          <a:off x="0" y="0"/>
+          <a:ext cx="0" cy="0"/>
+          <a:chOff x="0" y="0"/>
+          <a:chExt cx="0" cy="0"/>
+        </a:xfrm>
+      </p:grpSpPr>
+      <p:sp>
+        <p:nvSpPr>
+          <p:cNvPr id="2" name="Title 1">
+            <a:extLst>
+              <a:ext uri="{FF2B5EF4-FFF2-40B4-BE49-F238E27FC236}">
+                <a16:creationId xmlns:a16="http://schemas.microsoft.com/office/drawing/2014/main" id="{4552A926-B3F6-4308-9CCE-B6858A3418E6}"/>
+              </a:ext>
+            </a:extLst>
+          </p:cNvPr>
+          <p:cNvSpPr>
+            <a:spLocks noGrp="1"/>
+          </p:cNvSpPr>
+          <p:nvPr>
+            <p:ph type="title"/>
+          </p:nvPr>
+        </p:nvSpPr>
+        <p:spPr/>
+        <p:txBody>
+          <a:bodyPr/>
+          <a:lstStyle/>
+          <a:p>
+            <a:r>
+              <a:rPr lang="en-US" dirty="0"/>
+              <a:t>Quick Quiz!</a:t>
+            </a:r>
+          </a:p>
+        </p:txBody>
+      </p:sp>
+      <p:sp>
+        <p:nvSpPr>
+          <p:cNvPr id="3" name="Content Placeholder 2">
+            <a:extLst>
+              <a:ext uri="{FF2B5EF4-FFF2-40B4-BE49-F238E27FC236}">
+                <a16:creationId xmlns:a16="http://schemas.microsoft.com/office/drawing/2014/main" id="{5CD35CED-AD7F-442F-AE0F-1E38427143B1}"/>
+              </a:ext>
+            </a:extLst>
+          </p:cNvPr>
+          <p:cNvSpPr>
+            <a:spLocks noGrp="1"/>
+          </p:cNvSpPr>
+          <p:nvPr>
+            <p:ph idx="1"/>
+          </p:nvPr>
+        </p:nvSpPr>
+        <p:spPr/>
+        <p:txBody>
+          <a:bodyPr/>
+          <a:lstStyle/>
+          <a:p>
+            <a:r>
+              <a:rPr lang="en-US" dirty="0"/>
+              <a:t>How well do you understand </a:t>
+            </a:r>
+            <a:r>
+              <a:rPr lang="en-US" b="1" dirty="0"/>
+              <a:t>pointers </a:t>
+            </a:r>
+            <a:r>
+              <a:rPr lang="en-US" dirty="0"/>
+              <a:t>and </a:t>
+            </a:r>
+            <a:r>
+              <a:rPr lang="en-US" b="1" dirty="0"/>
+              <a:t>string manipulation</a:t>
+            </a:r>
+            <a:r>
+              <a:rPr lang="en-US" dirty="0"/>
+              <a:t>?</a:t>
+            </a:r>
+          </a:p>
+          <a:p>
+            <a:r>
+              <a:rPr lang="en-US" dirty="0"/>
+              <a:t>A practice lab is available on my website: There is one to practice </a:t>
+            </a:r>
+            <a:r>
+              <a:rPr lang="en-US" b="1" dirty="0"/>
+              <a:t>user input</a:t>
+            </a:r>
+            <a:r>
+              <a:rPr lang="en-US" dirty="0"/>
+              <a:t>, and one to practice </a:t>
+            </a:r>
+            <a:r>
+              <a:rPr lang="en-US" b="1" dirty="0"/>
+              <a:t>linked lists</a:t>
+            </a:r>
+            <a:r>
+              <a:rPr lang="en-US" dirty="0"/>
+              <a:t>.</a:t>
+            </a:r>
+          </a:p>
+          <a:p>
+            <a:pPr marL="0" indent="0">
+              <a:buNone/>
+            </a:pPr>
+            <a:endParaRPr lang="en-US" dirty="0"/>
+          </a:p>
+        </p:txBody>
+      </p:sp>
+    </p:spTree>
+    <p:extLst>
+      <p:ext uri="{BB962C8B-B14F-4D97-AF65-F5344CB8AC3E}">
+        <p14:creationId xmlns:p14="http://schemas.microsoft.com/office/powerpoint/2010/main" val="2994323884"/>
+      </p:ext>
+    </p:extLst>
+  </p:cSld>
+  <p:clrMapOvr>
+    <a:masterClrMapping/>
+  </p:clrMapOvr>
+</p:sld>
+</file>
+
+<file path=ppt/slides/slide20.xml><?xml version="1.0" encoding="utf-8"?>
 <p:sld xmlns:a="http://schemas.openxmlformats.org/drawingml/2006/main" xmlns:r="http://schemas.openxmlformats.org/officeDocument/2006/relationships" xmlns:p="http://schemas.openxmlformats.org/presentationml/2006/main">
   <p:cSld>
     <p:spTree>
@@ -9516,306 +10579,7 @@
 </p:sld>
 </file>
 
-<file path=ppt/slides/slide2.xml><?xml version="1.0" encoding="utf-8"?>
-<p:sld xmlns:a="http://schemas.openxmlformats.org/drawingml/2006/main" xmlns:r="http://schemas.openxmlformats.org/officeDocument/2006/relationships" xmlns:p="http://schemas.openxmlformats.org/presentationml/2006/main">
-  <p:cSld>
-    <p:spTree>
-      <p:nvGrpSpPr>
-        <p:cNvPr id="1" name=""/>
-        <p:cNvGrpSpPr/>
-        <p:nvPr/>
-      </p:nvGrpSpPr>
-      <p:grpSpPr>
-        <a:xfrm>
-          <a:off x="0" y="0"/>
-          <a:ext cx="0" cy="0"/>
-          <a:chOff x="0" y="0"/>
-          <a:chExt cx="0" cy="0"/>
-        </a:xfrm>
-      </p:grpSpPr>
-      <p:sp>
-        <p:nvSpPr>
-          <p:cNvPr id="2" name="Title 1">
-            <a:extLst>
-              <a:ext uri="{FF2B5EF4-FFF2-40B4-BE49-F238E27FC236}">
-                <a16:creationId xmlns:a16="http://schemas.microsoft.com/office/drawing/2014/main" id="{0E1EAB50-E6A4-44AD-89C0-0AD358E05D2A}"/>
-              </a:ext>
-            </a:extLst>
-          </p:cNvPr>
-          <p:cNvSpPr>
-            <a:spLocks noGrp="1"/>
-          </p:cNvSpPr>
-          <p:nvPr>
-            <p:ph type="title"/>
-          </p:nvPr>
-        </p:nvSpPr>
-        <p:spPr/>
-        <p:txBody>
-          <a:bodyPr/>
-          <a:lstStyle/>
-          <a:p>
-            <a:r>
-              <a:rPr lang="en-US" dirty="0"/>
-              <a:t>A friendly reminder</a:t>
-            </a:r>
-          </a:p>
-        </p:txBody>
-      </p:sp>
-      <p:sp>
-        <p:nvSpPr>
-          <p:cNvPr id="3" name="Content Placeholder 2">
-            <a:extLst>
-              <a:ext uri="{FF2B5EF4-FFF2-40B4-BE49-F238E27FC236}">
-                <a16:creationId xmlns:a16="http://schemas.microsoft.com/office/drawing/2014/main" id="{9FEAB1FE-8921-46E4-B9E6-916D0F2374AF}"/>
-              </a:ext>
-            </a:extLst>
-          </p:cNvPr>
-          <p:cNvSpPr>
-            <a:spLocks noGrp="1"/>
-          </p:cNvSpPr>
-          <p:nvPr>
-            <p:ph idx="1"/>
-          </p:nvPr>
-        </p:nvSpPr>
-        <p:spPr/>
-        <p:txBody>
-          <a:bodyPr/>
-          <a:lstStyle/>
-          <a:p>
-            <a:r>
-              <a:rPr lang="en-US" dirty="0"/>
-              <a:t>Never return an array in C. </a:t>
-            </a:r>
-          </a:p>
-          <a:p>
-            <a:endParaRPr lang="en-US" dirty="0"/>
-          </a:p>
-          <a:p>
-            <a:r>
-              <a:rPr lang="en-US" b="1" dirty="0"/>
-              <a:t>Arrays don’t exist in C</a:t>
-            </a:r>
-            <a:r>
-              <a:rPr lang="en-US" dirty="0"/>
-              <a:t>. </a:t>
-            </a:r>
-          </a:p>
-          <a:p>
-            <a:endParaRPr lang="en-US" dirty="0"/>
-          </a:p>
-          <a:p>
-            <a:r>
-              <a:rPr lang="en-US" dirty="0"/>
-              <a:t>When you pass an array into a function, it becomes a </a:t>
-            </a:r>
-            <a:r>
-              <a:rPr lang="en-US" b="1" dirty="0"/>
-              <a:t>Pointer</a:t>
-            </a:r>
-            <a:r>
-              <a:rPr lang="en-US" dirty="0"/>
-              <a:t>.</a:t>
-            </a:r>
-          </a:p>
-          <a:p>
-            <a:endParaRPr lang="en-US" b="1" dirty="0"/>
-          </a:p>
-        </p:txBody>
-      </p:sp>
-    </p:spTree>
-    <p:extLst>
-      <p:ext uri="{BB962C8B-B14F-4D97-AF65-F5344CB8AC3E}">
-        <p14:creationId xmlns:p14="http://schemas.microsoft.com/office/powerpoint/2010/main" val="4008943010"/>
-      </p:ext>
-    </p:extLst>
-  </p:cSld>
-  <p:clrMapOvr>
-    <a:masterClrMapping/>
-  </p:clrMapOvr>
-  <p:timing>
-    <p:tnLst>
-      <p:par>
-        <p:cTn id="1" dur="indefinite" restart="never" nodeType="tmRoot">
-          <p:childTnLst>
-            <p:seq concurrent="1" nextAc="seek">
-              <p:cTn id="2" dur="indefinite" nodeType="mainSeq">
-                <p:childTnLst>
-                  <p:par>
-                    <p:cTn id="3" fill="hold">
-                      <p:stCondLst>
-                        <p:cond delay="indefinite"/>
-                      </p:stCondLst>
-                      <p:childTnLst>
-                        <p:par>
-                          <p:cTn id="4" fill="hold">
-                            <p:stCondLst>
-                              <p:cond delay="0"/>
-                            </p:stCondLst>
-                            <p:childTnLst>
-                              <p:par>
-                                <p:cTn id="5" presetID="1" presetClass="entr" presetSubtype="0" fill="hold" grpId="0" nodeType="clickEffect">
-                                  <p:stCondLst>
-                                    <p:cond delay="0"/>
-                                  </p:stCondLst>
-                                  <p:childTnLst>
-                                    <p:set>
-                                      <p:cBhvr>
-                                        <p:cTn id="6" dur="1" fill="hold">
-                                          <p:stCondLst>
-                                            <p:cond delay="0"/>
-                                          </p:stCondLst>
-                                        </p:cTn>
-                                        <p:tgtEl>
-                                          <p:spTgt spid="3">
-                                            <p:txEl>
-                                              <p:pRg st="0" end="0"/>
-                                            </p:txEl>
-                                          </p:spTgt>
-                                        </p:tgtEl>
-                                        <p:attrNameLst>
-                                          <p:attrName>style.visibility</p:attrName>
-                                        </p:attrNameLst>
-                                      </p:cBhvr>
-                                      <p:to>
-                                        <p:strVal val="visible"/>
-                                      </p:to>
-                                    </p:set>
-                                  </p:childTnLst>
-                                </p:cTn>
-                              </p:par>
-                            </p:childTnLst>
-                          </p:cTn>
-                        </p:par>
-                      </p:childTnLst>
-                    </p:cTn>
-                  </p:par>
-                  <p:par>
-                    <p:cTn id="7" fill="hold">
-                      <p:stCondLst>
-                        <p:cond delay="indefinite"/>
-                      </p:stCondLst>
-                      <p:childTnLst>
-                        <p:par>
-                          <p:cTn id="8" fill="hold">
-                            <p:stCondLst>
-                              <p:cond delay="0"/>
-                            </p:stCondLst>
-                            <p:childTnLst>
-                              <p:par>
-                                <p:cTn id="9" presetID="1" presetClass="entr" presetSubtype="0" fill="hold" grpId="0" nodeType="clickEffect">
-                                  <p:stCondLst>
-                                    <p:cond delay="0"/>
-                                  </p:stCondLst>
-                                  <p:childTnLst>
-                                    <p:set>
-                                      <p:cBhvr>
-                                        <p:cTn id="10" dur="1" fill="hold">
-                                          <p:stCondLst>
-                                            <p:cond delay="0"/>
-                                          </p:stCondLst>
-                                        </p:cTn>
-                                        <p:tgtEl>
-                                          <p:spTgt spid="3">
-                                            <p:txEl>
-                                              <p:pRg st="2" end="2"/>
-                                            </p:txEl>
-                                          </p:spTgt>
-                                        </p:tgtEl>
-                                        <p:attrNameLst>
-                                          <p:attrName>style.visibility</p:attrName>
-                                        </p:attrNameLst>
-                                      </p:cBhvr>
-                                      <p:to>
-                                        <p:strVal val="visible"/>
-                                      </p:to>
-                                    </p:set>
-                                  </p:childTnLst>
-                                </p:cTn>
-                              </p:par>
-                            </p:childTnLst>
-                          </p:cTn>
-                        </p:par>
-                      </p:childTnLst>
-                    </p:cTn>
-                  </p:par>
-                  <p:par>
-                    <p:cTn id="11" fill="hold">
-                      <p:stCondLst>
-                        <p:cond delay="indefinite"/>
-                      </p:stCondLst>
-                      <p:childTnLst>
-                        <p:par>
-                          <p:cTn id="12" fill="hold">
-                            <p:stCondLst>
-                              <p:cond delay="0"/>
-                            </p:stCondLst>
-                            <p:childTnLst>
-                              <p:par>
-                                <p:cTn id="13" presetID="1" presetClass="entr" presetSubtype="0" fill="hold" grpId="0" nodeType="clickEffect">
-                                  <p:stCondLst>
-                                    <p:cond delay="0"/>
-                                  </p:stCondLst>
-                                  <p:childTnLst>
-                                    <p:set>
-                                      <p:cBhvr>
-                                        <p:cTn id="14" dur="1" fill="hold">
-                                          <p:stCondLst>
-                                            <p:cond delay="0"/>
-                                          </p:stCondLst>
-                                        </p:cTn>
-                                        <p:tgtEl>
-                                          <p:spTgt spid="3">
-                                            <p:txEl>
-                                              <p:pRg st="4" end="4"/>
-                                            </p:txEl>
-                                          </p:spTgt>
-                                        </p:tgtEl>
-                                        <p:attrNameLst>
-                                          <p:attrName>style.visibility</p:attrName>
-                                        </p:attrNameLst>
-                                      </p:cBhvr>
-                                      <p:to>
-                                        <p:strVal val="visible"/>
-                                      </p:to>
-                                    </p:set>
-                                  </p:childTnLst>
-                                </p:cTn>
-                              </p:par>
-                            </p:childTnLst>
-                          </p:cTn>
-                        </p:par>
-                      </p:childTnLst>
-                    </p:cTn>
-                  </p:par>
-                </p:childTnLst>
-              </p:cTn>
-              <p:prevCondLst>
-                <p:cond evt="onPrev" delay="0">
-                  <p:tgtEl>
-                    <p:sldTgt/>
-                  </p:tgtEl>
-                </p:cond>
-              </p:prevCondLst>
-              <p:nextCondLst>
-                <p:cond evt="onNext" delay="0">
-                  <p:tgtEl>
-                    <p:sldTgt/>
-                  </p:tgtEl>
-                </p:cond>
-              </p:nextCondLst>
-            </p:seq>
-          </p:childTnLst>
-        </p:cTn>
-      </p:par>
-    </p:tnLst>
-    <p:bldLst>
-      <p:bldP spid="3" grpId="0" build="p"/>
-    </p:bldLst>
-  </p:timing>
-</p:sld>
-</file>
-
-<file path=ppt/slides/slide20.xml><?xml version="1.0" encoding="utf-8"?>
+<file path=ppt/slides/slide21.xml><?xml version="1.0" encoding="utf-8"?>
 <p:sld xmlns:a="http://schemas.openxmlformats.org/drawingml/2006/main" xmlns:r="http://schemas.openxmlformats.org/officeDocument/2006/relationships" xmlns:p="http://schemas.openxmlformats.org/presentationml/2006/main">
   <p:cSld>
     <p:spTree>
@@ -10073,7 +10837,7 @@
 </p:sld>
 </file>
 
-<file path=ppt/slides/slide21.xml><?xml version="1.0" encoding="utf-8"?>
+<file path=ppt/slides/slide22.xml><?xml version="1.0" encoding="utf-8"?>
 <p:sld xmlns:a="http://schemas.openxmlformats.org/drawingml/2006/main" xmlns:r="http://schemas.openxmlformats.org/officeDocument/2006/relationships" xmlns:p="http://schemas.openxmlformats.org/presentationml/2006/main">
   <p:cSld>
     <p:spTree>
@@ -10328,7 +11092,7 @@
 </p:sld>
 </file>
 
-<file path=ppt/slides/slide22.xml><?xml version="1.0" encoding="utf-8"?>
+<file path=ppt/slides/slide23.xml><?xml version="1.0" encoding="utf-8"?>
 <p:sld xmlns:a="http://schemas.openxmlformats.org/drawingml/2006/main" xmlns:r="http://schemas.openxmlformats.org/officeDocument/2006/relationships" xmlns:p="http://schemas.openxmlformats.org/presentationml/2006/main">
   <p:cSld>
     <p:spTree>
@@ -10583,7 +11347,7 @@
 </p:sld>
 </file>
 
-<file path=ppt/slides/slide23.xml><?xml version="1.0" encoding="utf-8"?>
+<file path=ppt/slides/slide24.xml><?xml version="1.0" encoding="utf-8"?>
 <p:sld xmlns:a="http://schemas.openxmlformats.org/drawingml/2006/main" xmlns:r="http://schemas.openxmlformats.org/officeDocument/2006/relationships" xmlns:p="http://schemas.openxmlformats.org/presentationml/2006/main">
   <p:cSld>
     <p:bg>
@@ -10886,7 +11650,7 @@
 </p:sld>
 </file>
 
-<file path=ppt/slides/slide24.xml><?xml version="1.0" encoding="utf-8"?>
+<file path=ppt/slides/slide25.xml><?xml version="1.0" encoding="utf-8"?>
 <p:sld xmlns:a="http://schemas.openxmlformats.org/drawingml/2006/main" xmlns:r="http://schemas.openxmlformats.org/officeDocument/2006/relationships" xmlns:p="http://schemas.openxmlformats.org/presentationml/2006/main">
   <p:cSld>
     <p:spTree>
@@ -11157,7 +11921,7 @@
 </p:sld>
 </file>
 
-<file path=ppt/slides/slide25.xml><?xml version="1.0" encoding="utf-8"?>
+<file path=ppt/slides/slide26.xml><?xml version="1.0" encoding="utf-8"?>
 <p:sld xmlns:a="http://schemas.openxmlformats.org/drawingml/2006/main" xmlns:r="http://schemas.openxmlformats.org/officeDocument/2006/relationships" xmlns:p="http://schemas.openxmlformats.org/presentationml/2006/main">
   <p:cSld>
     <p:spTree>
@@ -11439,7 +12203,7 @@
 </p:sld>
 </file>
 
-<file path=ppt/slides/slide26.xml><?xml version="1.0" encoding="utf-8"?>
+<file path=ppt/slides/slide27.xml><?xml version="1.0" encoding="utf-8"?>
 <p:sld xmlns:a="http://schemas.openxmlformats.org/drawingml/2006/main" xmlns:r="http://schemas.openxmlformats.org/officeDocument/2006/relationships" xmlns:p="http://schemas.openxmlformats.org/presentationml/2006/main">
   <p:cSld>
     <p:spTree>
@@ -12371,7 +13135,7 @@
 </p:sld>
 </file>
 
-<file path=ppt/slides/slide27.xml><?xml version="1.0" encoding="utf-8"?>
+<file path=ppt/slides/slide28.xml><?xml version="1.0" encoding="utf-8"?>
 <p:sld xmlns:a="http://schemas.openxmlformats.org/drawingml/2006/main" xmlns:r="http://schemas.openxmlformats.org/officeDocument/2006/relationships" xmlns:p="http://schemas.openxmlformats.org/presentationml/2006/main">
   <p:cSld>
     <p:bg>
@@ -12674,7 +13438,7 @@
 </p:sld>
 </file>
 
-<file path=ppt/slides/slide28.xml><?xml version="1.0" encoding="utf-8"?>
+<file path=ppt/slides/slide29.xml><?xml version="1.0" encoding="utf-8"?>
 <p:sld xmlns:a="http://schemas.openxmlformats.org/drawingml/2006/main" xmlns:r="http://schemas.openxmlformats.org/officeDocument/2006/relationships" xmlns:p="http://schemas.openxmlformats.org/presentationml/2006/main">
   <p:cSld>
     <p:spTree>
@@ -13235,7 +13999,306 @@
 </p:sld>
 </file>
 
-<file path=ppt/slides/slide29.xml><?xml version="1.0" encoding="utf-8"?>
+<file path=ppt/slides/slide3.xml><?xml version="1.0" encoding="utf-8"?>
+<p:sld xmlns:a="http://schemas.openxmlformats.org/drawingml/2006/main" xmlns:r="http://schemas.openxmlformats.org/officeDocument/2006/relationships" xmlns:p="http://schemas.openxmlformats.org/presentationml/2006/main">
+  <p:cSld>
+    <p:spTree>
+      <p:nvGrpSpPr>
+        <p:cNvPr id="1" name=""/>
+        <p:cNvGrpSpPr/>
+        <p:nvPr/>
+      </p:nvGrpSpPr>
+      <p:grpSpPr>
+        <a:xfrm>
+          <a:off x="0" y="0"/>
+          <a:ext cx="0" cy="0"/>
+          <a:chOff x="0" y="0"/>
+          <a:chExt cx="0" cy="0"/>
+        </a:xfrm>
+      </p:grpSpPr>
+      <p:sp>
+        <p:nvSpPr>
+          <p:cNvPr id="2" name="Title 1">
+            <a:extLst>
+              <a:ext uri="{FF2B5EF4-FFF2-40B4-BE49-F238E27FC236}">
+                <a16:creationId xmlns:a16="http://schemas.microsoft.com/office/drawing/2014/main" id="{0E1EAB50-E6A4-44AD-89C0-0AD358E05D2A}"/>
+              </a:ext>
+            </a:extLst>
+          </p:cNvPr>
+          <p:cNvSpPr>
+            <a:spLocks noGrp="1"/>
+          </p:cNvSpPr>
+          <p:nvPr>
+            <p:ph type="title"/>
+          </p:nvPr>
+        </p:nvSpPr>
+        <p:spPr/>
+        <p:txBody>
+          <a:bodyPr/>
+          <a:lstStyle/>
+          <a:p>
+            <a:r>
+              <a:rPr lang="en-US" dirty="0"/>
+              <a:t>A friendly reminder</a:t>
+            </a:r>
+          </a:p>
+        </p:txBody>
+      </p:sp>
+      <p:sp>
+        <p:nvSpPr>
+          <p:cNvPr id="3" name="Content Placeholder 2">
+            <a:extLst>
+              <a:ext uri="{FF2B5EF4-FFF2-40B4-BE49-F238E27FC236}">
+                <a16:creationId xmlns:a16="http://schemas.microsoft.com/office/drawing/2014/main" id="{9FEAB1FE-8921-46E4-B9E6-916D0F2374AF}"/>
+              </a:ext>
+            </a:extLst>
+          </p:cNvPr>
+          <p:cNvSpPr>
+            <a:spLocks noGrp="1"/>
+          </p:cNvSpPr>
+          <p:nvPr>
+            <p:ph idx="1"/>
+          </p:nvPr>
+        </p:nvSpPr>
+        <p:spPr/>
+        <p:txBody>
+          <a:bodyPr/>
+          <a:lstStyle/>
+          <a:p>
+            <a:r>
+              <a:rPr lang="en-US" dirty="0"/>
+              <a:t>Never return an array in C. </a:t>
+            </a:r>
+          </a:p>
+          <a:p>
+            <a:endParaRPr lang="en-US" dirty="0"/>
+          </a:p>
+          <a:p>
+            <a:r>
+              <a:rPr lang="en-US" b="1" dirty="0"/>
+              <a:t>Arrays don’t exist in C</a:t>
+            </a:r>
+            <a:r>
+              <a:rPr lang="en-US" dirty="0"/>
+              <a:t>. </a:t>
+            </a:r>
+          </a:p>
+          <a:p>
+            <a:endParaRPr lang="en-US" dirty="0"/>
+          </a:p>
+          <a:p>
+            <a:r>
+              <a:rPr lang="en-US" dirty="0"/>
+              <a:t>When you pass an array into a function, it becomes a </a:t>
+            </a:r>
+            <a:r>
+              <a:rPr lang="en-US" b="1" dirty="0"/>
+              <a:t>Pointer</a:t>
+            </a:r>
+            <a:r>
+              <a:rPr lang="en-US" dirty="0"/>
+              <a:t>.</a:t>
+            </a:r>
+          </a:p>
+          <a:p>
+            <a:endParaRPr lang="en-US" b="1" dirty="0"/>
+          </a:p>
+        </p:txBody>
+      </p:sp>
+    </p:spTree>
+    <p:extLst>
+      <p:ext uri="{BB962C8B-B14F-4D97-AF65-F5344CB8AC3E}">
+        <p14:creationId xmlns:p14="http://schemas.microsoft.com/office/powerpoint/2010/main" val="4008943010"/>
+      </p:ext>
+    </p:extLst>
+  </p:cSld>
+  <p:clrMapOvr>
+    <a:masterClrMapping/>
+  </p:clrMapOvr>
+  <p:timing>
+    <p:tnLst>
+      <p:par>
+        <p:cTn id="1" dur="indefinite" restart="never" nodeType="tmRoot">
+          <p:childTnLst>
+            <p:seq concurrent="1" nextAc="seek">
+              <p:cTn id="2" dur="indefinite" nodeType="mainSeq">
+                <p:childTnLst>
+                  <p:par>
+                    <p:cTn id="3" fill="hold">
+                      <p:stCondLst>
+                        <p:cond delay="indefinite"/>
+                      </p:stCondLst>
+                      <p:childTnLst>
+                        <p:par>
+                          <p:cTn id="4" fill="hold">
+                            <p:stCondLst>
+                              <p:cond delay="0"/>
+                            </p:stCondLst>
+                            <p:childTnLst>
+                              <p:par>
+                                <p:cTn id="5" presetID="1" presetClass="entr" presetSubtype="0" fill="hold" grpId="0" nodeType="clickEffect">
+                                  <p:stCondLst>
+                                    <p:cond delay="0"/>
+                                  </p:stCondLst>
+                                  <p:childTnLst>
+                                    <p:set>
+                                      <p:cBhvr>
+                                        <p:cTn id="6" dur="1" fill="hold">
+                                          <p:stCondLst>
+                                            <p:cond delay="0"/>
+                                          </p:stCondLst>
+                                        </p:cTn>
+                                        <p:tgtEl>
+                                          <p:spTgt spid="3">
+                                            <p:txEl>
+                                              <p:pRg st="0" end="0"/>
+                                            </p:txEl>
+                                          </p:spTgt>
+                                        </p:tgtEl>
+                                        <p:attrNameLst>
+                                          <p:attrName>style.visibility</p:attrName>
+                                        </p:attrNameLst>
+                                      </p:cBhvr>
+                                      <p:to>
+                                        <p:strVal val="visible"/>
+                                      </p:to>
+                                    </p:set>
+                                  </p:childTnLst>
+                                </p:cTn>
+                              </p:par>
+                            </p:childTnLst>
+                          </p:cTn>
+                        </p:par>
+                      </p:childTnLst>
+                    </p:cTn>
+                  </p:par>
+                  <p:par>
+                    <p:cTn id="7" fill="hold">
+                      <p:stCondLst>
+                        <p:cond delay="indefinite"/>
+                      </p:stCondLst>
+                      <p:childTnLst>
+                        <p:par>
+                          <p:cTn id="8" fill="hold">
+                            <p:stCondLst>
+                              <p:cond delay="0"/>
+                            </p:stCondLst>
+                            <p:childTnLst>
+                              <p:par>
+                                <p:cTn id="9" presetID="1" presetClass="entr" presetSubtype="0" fill="hold" grpId="0" nodeType="clickEffect">
+                                  <p:stCondLst>
+                                    <p:cond delay="0"/>
+                                  </p:stCondLst>
+                                  <p:childTnLst>
+                                    <p:set>
+                                      <p:cBhvr>
+                                        <p:cTn id="10" dur="1" fill="hold">
+                                          <p:stCondLst>
+                                            <p:cond delay="0"/>
+                                          </p:stCondLst>
+                                        </p:cTn>
+                                        <p:tgtEl>
+                                          <p:spTgt spid="3">
+                                            <p:txEl>
+                                              <p:pRg st="2" end="2"/>
+                                            </p:txEl>
+                                          </p:spTgt>
+                                        </p:tgtEl>
+                                        <p:attrNameLst>
+                                          <p:attrName>style.visibility</p:attrName>
+                                        </p:attrNameLst>
+                                      </p:cBhvr>
+                                      <p:to>
+                                        <p:strVal val="visible"/>
+                                      </p:to>
+                                    </p:set>
+                                  </p:childTnLst>
+                                </p:cTn>
+                              </p:par>
+                            </p:childTnLst>
+                          </p:cTn>
+                        </p:par>
+                      </p:childTnLst>
+                    </p:cTn>
+                  </p:par>
+                  <p:par>
+                    <p:cTn id="11" fill="hold">
+                      <p:stCondLst>
+                        <p:cond delay="indefinite"/>
+                      </p:stCondLst>
+                      <p:childTnLst>
+                        <p:par>
+                          <p:cTn id="12" fill="hold">
+                            <p:stCondLst>
+                              <p:cond delay="0"/>
+                            </p:stCondLst>
+                            <p:childTnLst>
+                              <p:par>
+                                <p:cTn id="13" presetID="1" presetClass="entr" presetSubtype="0" fill="hold" grpId="0" nodeType="clickEffect">
+                                  <p:stCondLst>
+                                    <p:cond delay="0"/>
+                                  </p:stCondLst>
+                                  <p:childTnLst>
+                                    <p:set>
+                                      <p:cBhvr>
+                                        <p:cTn id="14" dur="1" fill="hold">
+                                          <p:stCondLst>
+                                            <p:cond delay="0"/>
+                                          </p:stCondLst>
+                                        </p:cTn>
+                                        <p:tgtEl>
+                                          <p:spTgt spid="3">
+                                            <p:txEl>
+                                              <p:pRg st="4" end="4"/>
+                                            </p:txEl>
+                                          </p:spTgt>
+                                        </p:tgtEl>
+                                        <p:attrNameLst>
+                                          <p:attrName>style.visibility</p:attrName>
+                                        </p:attrNameLst>
+                                      </p:cBhvr>
+                                      <p:to>
+                                        <p:strVal val="visible"/>
+                                      </p:to>
+                                    </p:set>
+                                  </p:childTnLst>
+                                </p:cTn>
+                              </p:par>
+                            </p:childTnLst>
+                          </p:cTn>
+                        </p:par>
+                      </p:childTnLst>
+                    </p:cTn>
+                  </p:par>
+                </p:childTnLst>
+              </p:cTn>
+              <p:prevCondLst>
+                <p:cond evt="onPrev" delay="0">
+                  <p:tgtEl>
+                    <p:sldTgt/>
+                  </p:tgtEl>
+                </p:cond>
+              </p:prevCondLst>
+              <p:nextCondLst>
+                <p:cond evt="onNext" delay="0">
+                  <p:tgtEl>
+                    <p:sldTgt/>
+                  </p:tgtEl>
+                </p:cond>
+              </p:nextCondLst>
+            </p:seq>
+          </p:childTnLst>
+        </p:cTn>
+      </p:par>
+    </p:tnLst>
+    <p:bldLst>
+      <p:bldP spid="3" grpId="0" build="p"/>
+    </p:bldLst>
+  </p:timing>
+</p:sld>
+</file>
+
+<file path=ppt/slides/slide30.xml><?xml version="1.0" encoding="utf-8"?>
 <p:sld xmlns:a="http://schemas.openxmlformats.org/drawingml/2006/main" xmlns:r="http://schemas.openxmlformats.org/officeDocument/2006/relationships" xmlns:p="http://schemas.openxmlformats.org/presentationml/2006/main">
   <p:cSld>
     <p:bg>
@@ -13473,6 +14536,816 @@
                   <a:schemeClr val="bg1"/>
                 </a:solidFill>
               </a:rPr>
+              <a:t>Void Pointers</a:t>
+            </a:r>
+          </a:p>
+        </p:txBody>
+      </p:sp>
+      <p:cxnSp>
+        <p:nvCxnSpPr>
+          <p:cNvPr id="12" name="Straight Connector 11">
+            <a:extLst>
+              <a:ext uri="{FF2B5EF4-FFF2-40B4-BE49-F238E27FC236}">
+                <a16:creationId xmlns:a16="http://schemas.microsoft.com/office/drawing/2014/main" id="{87ADDECF-37FB-45A1-BAD3-6252E3064A1E}"/>
+              </a:ext>
+              <a:ext uri="{C183D7F6-B498-43B3-948B-1728B52AA6E4}">
+                <adec:decorative xmlns:adec="http://schemas.microsoft.com/office/drawing/2017/decorative" val="1"/>
+              </a:ext>
+            </a:extLst>
+          </p:cNvPr>
+          <p:cNvCxnSpPr>
+            <a:cxnSpLocks noGrp="1" noRot="1" noChangeAspect="1" noMove="1" noResize="1" noEditPoints="1" noAdjustHandles="1" noChangeArrowheads="1" noChangeShapeType="1"/>
+          </p:cNvCxnSpPr>
+          <p:nvPr>
+            <p:extLst>
+              <p:ext uri="{386F3935-93C4-4BCD-93E2-E3B085C9AB24}">
+                <p16:designElem xmlns:p16="http://schemas.microsoft.com/office/powerpoint/2015/main" val="1"/>
+              </p:ext>
+            </p:extLst>
+          </p:nvPr>
+        </p:nvCxnSpPr>
+        <p:spPr>
+          <a:xfrm>
+            <a:off x="1483042" y="2267682"/>
+            <a:ext cx="9273858" cy="0"/>
+          </a:xfrm>
+          <a:prstGeom prst="line">
+            <a:avLst/>
+          </a:prstGeom>
+        </p:spPr>
+        <p:style>
+          <a:lnRef idx="2">
+            <a:schemeClr val="accent1"/>
+          </a:lnRef>
+          <a:fillRef idx="0">
+            <a:schemeClr val="accent1"/>
+          </a:fillRef>
+          <a:effectRef idx="1">
+            <a:schemeClr val="accent1"/>
+          </a:effectRef>
+          <a:fontRef idx="minor">
+            <a:schemeClr val="tx1"/>
+          </a:fontRef>
+        </p:style>
+      </p:cxnSp>
+    </p:spTree>
+    <p:extLst>
+      <p:ext uri="{BB962C8B-B14F-4D97-AF65-F5344CB8AC3E}">
+        <p14:creationId xmlns:p14="http://schemas.microsoft.com/office/powerpoint/2010/main" val="2487243942"/>
+      </p:ext>
+    </p:extLst>
+  </p:cSld>
+  <p:clrMapOvr>
+    <a:masterClrMapping/>
+  </p:clrMapOvr>
+</p:sld>
+</file>
+
+<file path=ppt/slides/slide31.xml><?xml version="1.0" encoding="utf-8"?>
+<p:sld xmlns:a="http://schemas.openxmlformats.org/drawingml/2006/main" xmlns:r="http://schemas.openxmlformats.org/officeDocument/2006/relationships" xmlns:p="http://schemas.openxmlformats.org/presentationml/2006/main">
+  <p:cSld>
+    <p:spTree>
+      <p:nvGrpSpPr>
+        <p:cNvPr id="1" name=""/>
+        <p:cNvGrpSpPr/>
+        <p:nvPr/>
+      </p:nvGrpSpPr>
+      <p:grpSpPr>
+        <a:xfrm>
+          <a:off x="0" y="0"/>
+          <a:ext cx="0" cy="0"/>
+          <a:chOff x="0" y="0"/>
+          <a:chExt cx="0" cy="0"/>
+        </a:xfrm>
+      </p:grpSpPr>
+      <p:sp>
+        <p:nvSpPr>
+          <p:cNvPr id="2" name="Title 1">
+            <a:extLst>
+              <a:ext uri="{FF2B5EF4-FFF2-40B4-BE49-F238E27FC236}">
+                <a16:creationId xmlns:a16="http://schemas.microsoft.com/office/drawing/2014/main" id="{FAD7697B-5443-4616-819C-DC1B6F9D4DE3}"/>
+              </a:ext>
+            </a:extLst>
+          </p:cNvPr>
+          <p:cNvSpPr>
+            <a:spLocks noGrp="1"/>
+          </p:cNvSpPr>
+          <p:nvPr>
+            <p:ph type="title"/>
+          </p:nvPr>
+        </p:nvSpPr>
+        <p:spPr/>
+        <p:txBody>
+          <a:bodyPr/>
+          <a:lstStyle/>
+          <a:p>
+            <a:r>
+              <a:rPr lang="en-US" dirty="0"/>
+              <a:t>What is a </a:t>
+            </a:r>
+            <a:r>
+              <a:rPr lang="en-US" b="1" dirty="0"/>
+              <a:t>void pointer</a:t>
+            </a:r>
+            <a:r>
+              <a:rPr lang="en-US" dirty="0"/>
+              <a:t>?</a:t>
+            </a:r>
+          </a:p>
+        </p:txBody>
+      </p:sp>
+      <p:sp>
+        <p:nvSpPr>
+          <p:cNvPr id="3" name="Content Placeholder 2">
+            <a:extLst>
+              <a:ext uri="{FF2B5EF4-FFF2-40B4-BE49-F238E27FC236}">
+                <a16:creationId xmlns:a16="http://schemas.microsoft.com/office/drawing/2014/main" id="{30220A0B-D33A-40B3-88D0-E6B6C7F2F090}"/>
+              </a:ext>
+            </a:extLst>
+          </p:cNvPr>
+          <p:cNvSpPr>
+            <a:spLocks noGrp="1"/>
+          </p:cNvSpPr>
+          <p:nvPr>
+            <p:ph idx="1"/>
+          </p:nvPr>
+        </p:nvSpPr>
+        <p:spPr/>
+        <p:txBody>
+          <a:bodyPr/>
+          <a:lstStyle/>
+          <a:p>
+            <a:r>
+              <a:rPr lang="en-US" dirty="0"/>
+              <a:t>Think of a </a:t>
+            </a:r>
+            <a:r>
+              <a:rPr lang="en-US" b="1" dirty="0"/>
+              <a:t>void pointer </a:t>
+            </a:r>
+            <a:r>
+              <a:rPr lang="en-US" dirty="0"/>
+              <a:t>like a </a:t>
+            </a:r>
+            <a:r>
+              <a:rPr lang="en-US" b="1" dirty="0"/>
+              <a:t>universal</a:t>
+            </a:r>
+            <a:r>
+              <a:rPr lang="en-US" dirty="0"/>
+              <a:t> pointer</a:t>
+            </a:r>
+          </a:p>
+          <a:p>
+            <a:r>
+              <a:rPr lang="en-US" dirty="0"/>
+              <a:t>It can point to </a:t>
+            </a:r>
+            <a:r>
+              <a:rPr lang="en-US" b="1" dirty="0"/>
+              <a:t>anything</a:t>
+            </a:r>
+            <a:r>
+              <a:rPr lang="en-US" dirty="0"/>
+              <a:t>.</a:t>
+            </a:r>
+          </a:p>
+          <a:p>
+            <a:pPr marL="0" indent="0">
+              <a:buNone/>
+            </a:pPr>
+            <a:r>
+              <a:rPr lang="en-US" dirty="0"/>
+              <a:t>int x; float y;</a:t>
+            </a:r>
+          </a:p>
+          <a:p>
+            <a:pPr marL="0" indent="0">
+              <a:buNone/>
+            </a:pPr>
+            <a:r>
+              <a:rPr lang="en-US" dirty="0"/>
+              <a:t>void* </a:t>
+            </a:r>
+            <a:r>
+              <a:rPr lang="en-US" dirty="0" err="1"/>
+              <a:t>vp</a:t>
+            </a:r>
+            <a:r>
+              <a:rPr lang="en-US" dirty="0"/>
+              <a:t> = &amp;x; //good!</a:t>
+            </a:r>
+          </a:p>
+          <a:p>
+            <a:pPr marL="0" indent="0">
+              <a:buNone/>
+            </a:pPr>
+            <a:r>
+              <a:rPr lang="en-US" dirty="0" err="1"/>
+              <a:t>vp</a:t>
+            </a:r>
+            <a:r>
+              <a:rPr lang="en-US" dirty="0"/>
+              <a:t> = &amp;y; //good!</a:t>
+            </a:r>
+          </a:p>
+          <a:p>
+            <a:r>
+              <a:rPr lang="en-US" dirty="0"/>
+              <a:t>But… you can’t </a:t>
+            </a:r>
+            <a:r>
+              <a:rPr lang="en-US" b="1" dirty="0"/>
+              <a:t>access the data </a:t>
+            </a:r>
+            <a:r>
+              <a:rPr lang="en-US" dirty="0"/>
+              <a:t>from a void* without a cast…</a:t>
+            </a:r>
+          </a:p>
+          <a:p>
+            <a:endParaRPr lang="en-US" dirty="0"/>
+          </a:p>
+        </p:txBody>
+      </p:sp>
+    </p:spTree>
+    <p:extLst>
+      <p:ext uri="{BB962C8B-B14F-4D97-AF65-F5344CB8AC3E}">
+        <p14:creationId xmlns:p14="http://schemas.microsoft.com/office/powerpoint/2010/main" val="122893619"/>
+      </p:ext>
+    </p:extLst>
+  </p:cSld>
+  <p:clrMapOvr>
+    <a:masterClrMapping/>
+  </p:clrMapOvr>
+  <p:timing>
+    <p:tnLst>
+      <p:par>
+        <p:cTn id="1" dur="indefinite" restart="never" nodeType="tmRoot">
+          <p:childTnLst>
+            <p:seq concurrent="1" nextAc="seek">
+              <p:cTn id="2" dur="indefinite" nodeType="mainSeq">
+                <p:childTnLst>
+                  <p:par>
+                    <p:cTn id="3" fill="hold">
+                      <p:stCondLst>
+                        <p:cond delay="indefinite"/>
+                      </p:stCondLst>
+                      <p:childTnLst>
+                        <p:par>
+                          <p:cTn id="4" fill="hold">
+                            <p:stCondLst>
+                              <p:cond delay="0"/>
+                            </p:stCondLst>
+                            <p:childTnLst>
+                              <p:par>
+                                <p:cTn id="5" presetID="1" presetClass="entr" presetSubtype="0" fill="hold" grpId="0" nodeType="clickEffect">
+                                  <p:stCondLst>
+                                    <p:cond delay="0"/>
+                                  </p:stCondLst>
+                                  <p:childTnLst>
+                                    <p:set>
+                                      <p:cBhvr>
+                                        <p:cTn id="6" dur="1" fill="hold">
+                                          <p:stCondLst>
+                                            <p:cond delay="0"/>
+                                          </p:stCondLst>
+                                        </p:cTn>
+                                        <p:tgtEl>
+                                          <p:spTgt spid="3">
+                                            <p:txEl>
+                                              <p:pRg st="0" end="0"/>
+                                            </p:txEl>
+                                          </p:spTgt>
+                                        </p:tgtEl>
+                                        <p:attrNameLst>
+                                          <p:attrName>style.visibility</p:attrName>
+                                        </p:attrNameLst>
+                                      </p:cBhvr>
+                                      <p:to>
+                                        <p:strVal val="visible"/>
+                                      </p:to>
+                                    </p:set>
+                                  </p:childTnLst>
+                                </p:cTn>
+                              </p:par>
+                            </p:childTnLst>
+                          </p:cTn>
+                        </p:par>
+                      </p:childTnLst>
+                    </p:cTn>
+                  </p:par>
+                  <p:par>
+                    <p:cTn id="7" fill="hold">
+                      <p:stCondLst>
+                        <p:cond delay="indefinite"/>
+                      </p:stCondLst>
+                      <p:childTnLst>
+                        <p:par>
+                          <p:cTn id="8" fill="hold">
+                            <p:stCondLst>
+                              <p:cond delay="0"/>
+                            </p:stCondLst>
+                            <p:childTnLst>
+                              <p:par>
+                                <p:cTn id="9" presetID="1" presetClass="entr" presetSubtype="0" fill="hold" grpId="0" nodeType="clickEffect">
+                                  <p:stCondLst>
+                                    <p:cond delay="0"/>
+                                  </p:stCondLst>
+                                  <p:childTnLst>
+                                    <p:set>
+                                      <p:cBhvr>
+                                        <p:cTn id="10" dur="1" fill="hold">
+                                          <p:stCondLst>
+                                            <p:cond delay="0"/>
+                                          </p:stCondLst>
+                                        </p:cTn>
+                                        <p:tgtEl>
+                                          <p:spTgt spid="3">
+                                            <p:txEl>
+                                              <p:pRg st="1" end="1"/>
+                                            </p:txEl>
+                                          </p:spTgt>
+                                        </p:tgtEl>
+                                        <p:attrNameLst>
+                                          <p:attrName>style.visibility</p:attrName>
+                                        </p:attrNameLst>
+                                      </p:cBhvr>
+                                      <p:to>
+                                        <p:strVal val="visible"/>
+                                      </p:to>
+                                    </p:set>
+                                  </p:childTnLst>
+                                </p:cTn>
+                              </p:par>
+                            </p:childTnLst>
+                          </p:cTn>
+                        </p:par>
+                      </p:childTnLst>
+                    </p:cTn>
+                  </p:par>
+                  <p:par>
+                    <p:cTn id="11" fill="hold">
+                      <p:stCondLst>
+                        <p:cond delay="indefinite"/>
+                      </p:stCondLst>
+                      <p:childTnLst>
+                        <p:par>
+                          <p:cTn id="12" fill="hold">
+                            <p:stCondLst>
+                              <p:cond delay="0"/>
+                            </p:stCondLst>
+                            <p:childTnLst>
+                              <p:par>
+                                <p:cTn id="13" presetID="1" presetClass="entr" presetSubtype="0" fill="hold" grpId="0" nodeType="clickEffect">
+                                  <p:stCondLst>
+                                    <p:cond delay="0"/>
+                                  </p:stCondLst>
+                                  <p:childTnLst>
+                                    <p:set>
+                                      <p:cBhvr>
+                                        <p:cTn id="14" dur="1" fill="hold">
+                                          <p:stCondLst>
+                                            <p:cond delay="0"/>
+                                          </p:stCondLst>
+                                        </p:cTn>
+                                        <p:tgtEl>
+                                          <p:spTgt spid="3">
+                                            <p:txEl>
+                                              <p:pRg st="2" end="2"/>
+                                            </p:txEl>
+                                          </p:spTgt>
+                                        </p:tgtEl>
+                                        <p:attrNameLst>
+                                          <p:attrName>style.visibility</p:attrName>
+                                        </p:attrNameLst>
+                                      </p:cBhvr>
+                                      <p:to>
+                                        <p:strVal val="visible"/>
+                                      </p:to>
+                                    </p:set>
+                                  </p:childTnLst>
+                                </p:cTn>
+                              </p:par>
+                            </p:childTnLst>
+                          </p:cTn>
+                        </p:par>
+                      </p:childTnLst>
+                    </p:cTn>
+                  </p:par>
+                  <p:par>
+                    <p:cTn id="15" fill="hold">
+                      <p:stCondLst>
+                        <p:cond delay="indefinite"/>
+                      </p:stCondLst>
+                      <p:childTnLst>
+                        <p:par>
+                          <p:cTn id="16" fill="hold">
+                            <p:stCondLst>
+                              <p:cond delay="0"/>
+                            </p:stCondLst>
+                            <p:childTnLst>
+                              <p:par>
+                                <p:cTn id="17" presetID="1" presetClass="entr" presetSubtype="0" fill="hold" grpId="0" nodeType="clickEffect">
+                                  <p:stCondLst>
+                                    <p:cond delay="0"/>
+                                  </p:stCondLst>
+                                  <p:childTnLst>
+                                    <p:set>
+                                      <p:cBhvr>
+                                        <p:cTn id="18" dur="1" fill="hold">
+                                          <p:stCondLst>
+                                            <p:cond delay="0"/>
+                                          </p:stCondLst>
+                                        </p:cTn>
+                                        <p:tgtEl>
+                                          <p:spTgt spid="3">
+                                            <p:txEl>
+                                              <p:pRg st="3" end="3"/>
+                                            </p:txEl>
+                                          </p:spTgt>
+                                        </p:tgtEl>
+                                        <p:attrNameLst>
+                                          <p:attrName>style.visibility</p:attrName>
+                                        </p:attrNameLst>
+                                      </p:cBhvr>
+                                      <p:to>
+                                        <p:strVal val="visible"/>
+                                      </p:to>
+                                    </p:set>
+                                  </p:childTnLst>
+                                </p:cTn>
+                              </p:par>
+                            </p:childTnLst>
+                          </p:cTn>
+                        </p:par>
+                      </p:childTnLst>
+                    </p:cTn>
+                  </p:par>
+                  <p:par>
+                    <p:cTn id="19" fill="hold">
+                      <p:stCondLst>
+                        <p:cond delay="indefinite"/>
+                      </p:stCondLst>
+                      <p:childTnLst>
+                        <p:par>
+                          <p:cTn id="20" fill="hold">
+                            <p:stCondLst>
+                              <p:cond delay="0"/>
+                            </p:stCondLst>
+                            <p:childTnLst>
+                              <p:par>
+                                <p:cTn id="21" presetID="1" presetClass="entr" presetSubtype="0" fill="hold" grpId="0" nodeType="clickEffect">
+                                  <p:stCondLst>
+                                    <p:cond delay="0"/>
+                                  </p:stCondLst>
+                                  <p:childTnLst>
+                                    <p:set>
+                                      <p:cBhvr>
+                                        <p:cTn id="22" dur="1" fill="hold">
+                                          <p:stCondLst>
+                                            <p:cond delay="0"/>
+                                          </p:stCondLst>
+                                        </p:cTn>
+                                        <p:tgtEl>
+                                          <p:spTgt spid="3">
+                                            <p:txEl>
+                                              <p:pRg st="4" end="4"/>
+                                            </p:txEl>
+                                          </p:spTgt>
+                                        </p:tgtEl>
+                                        <p:attrNameLst>
+                                          <p:attrName>style.visibility</p:attrName>
+                                        </p:attrNameLst>
+                                      </p:cBhvr>
+                                      <p:to>
+                                        <p:strVal val="visible"/>
+                                      </p:to>
+                                    </p:set>
+                                  </p:childTnLst>
+                                </p:cTn>
+                              </p:par>
+                            </p:childTnLst>
+                          </p:cTn>
+                        </p:par>
+                      </p:childTnLst>
+                    </p:cTn>
+                  </p:par>
+                  <p:par>
+                    <p:cTn id="23" fill="hold">
+                      <p:stCondLst>
+                        <p:cond delay="indefinite"/>
+                      </p:stCondLst>
+                      <p:childTnLst>
+                        <p:par>
+                          <p:cTn id="24" fill="hold">
+                            <p:stCondLst>
+                              <p:cond delay="0"/>
+                            </p:stCondLst>
+                            <p:childTnLst>
+                              <p:par>
+                                <p:cTn id="25" presetID="1" presetClass="entr" presetSubtype="0" fill="hold" grpId="0" nodeType="clickEffect">
+                                  <p:stCondLst>
+                                    <p:cond delay="0"/>
+                                  </p:stCondLst>
+                                  <p:childTnLst>
+                                    <p:set>
+                                      <p:cBhvr>
+                                        <p:cTn id="26" dur="1" fill="hold">
+                                          <p:stCondLst>
+                                            <p:cond delay="0"/>
+                                          </p:stCondLst>
+                                        </p:cTn>
+                                        <p:tgtEl>
+                                          <p:spTgt spid="3">
+                                            <p:txEl>
+                                              <p:pRg st="5" end="5"/>
+                                            </p:txEl>
+                                          </p:spTgt>
+                                        </p:tgtEl>
+                                        <p:attrNameLst>
+                                          <p:attrName>style.visibility</p:attrName>
+                                        </p:attrNameLst>
+                                      </p:cBhvr>
+                                      <p:to>
+                                        <p:strVal val="visible"/>
+                                      </p:to>
+                                    </p:set>
+                                  </p:childTnLst>
+                                </p:cTn>
+                              </p:par>
+                            </p:childTnLst>
+                          </p:cTn>
+                        </p:par>
+                      </p:childTnLst>
+                    </p:cTn>
+                  </p:par>
+                </p:childTnLst>
+              </p:cTn>
+              <p:prevCondLst>
+                <p:cond evt="onPrev" delay="0">
+                  <p:tgtEl>
+                    <p:sldTgt/>
+                  </p:tgtEl>
+                </p:cond>
+              </p:prevCondLst>
+              <p:nextCondLst>
+                <p:cond evt="onNext" delay="0">
+                  <p:tgtEl>
+                    <p:sldTgt/>
+                  </p:tgtEl>
+                </p:cond>
+              </p:nextCondLst>
+            </p:seq>
+          </p:childTnLst>
+        </p:cTn>
+      </p:par>
+    </p:tnLst>
+    <p:bldLst>
+      <p:bldP spid="3" grpId="0" build="p"/>
+    </p:bldLst>
+  </p:timing>
+</p:sld>
+</file>
+
+<file path=ppt/slides/slide32.xml><?xml version="1.0" encoding="utf-8"?>
+<p:sld xmlns:a="http://schemas.openxmlformats.org/drawingml/2006/main" xmlns:r="http://schemas.openxmlformats.org/officeDocument/2006/relationships" xmlns:p="http://schemas.openxmlformats.org/presentationml/2006/main">
+  <p:cSld>
+    <p:bg>
+      <p:bgPr>
+        <a:solidFill>
+          <a:schemeClr val="bg1"/>
+        </a:solidFill>
+        <a:effectLst/>
+      </p:bgPr>
+    </p:bg>
+    <p:spTree>
+      <p:nvGrpSpPr>
+        <p:cNvPr id="1" name=""/>
+        <p:cNvGrpSpPr/>
+        <p:nvPr/>
+      </p:nvGrpSpPr>
+      <p:grpSpPr>
+        <a:xfrm>
+          <a:off x="0" y="0"/>
+          <a:ext cx="0" cy="0"/>
+          <a:chOff x="0" y="0"/>
+          <a:chExt cx="0" cy="0"/>
+        </a:xfrm>
+      </p:grpSpPr>
+      <p:sp>
+        <p:nvSpPr>
+          <p:cNvPr id="8" name="Rectangle 7">
+            <a:extLst>
+              <a:ext uri="{FF2B5EF4-FFF2-40B4-BE49-F238E27FC236}">
+                <a16:creationId xmlns:a16="http://schemas.microsoft.com/office/drawing/2014/main" id="{78A17A72-B88B-450E-835A-1C2722503AF2}"/>
+              </a:ext>
+              <a:ext uri="{C183D7F6-B498-43B3-948B-1728B52AA6E4}">
+                <adec:decorative xmlns:adec="http://schemas.microsoft.com/office/drawing/2017/decorative" val="1"/>
+              </a:ext>
+            </a:extLst>
+          </p:cNvPr>
+          <p:cNvSpPr>
+            <a:spLocks noGrp="1" noRot="1" noChangeAspect="1" noMove="1" noResize="1" noEditPoints="1" noAdjustHandles="1" noChangeArrowheads="1" noChangeShapeType="1" noTextEdit="1"/>
+          </p:cNvSpPr>
+          <p:nvPr>
+            <p:extLst>
+              <p:ext uri="{386F3935-93C4-4BCD-93E2-E3B085C9AB24}">
+                <p16:designElem xmlns:p16="http://schemas.microsoft.com/office/powerpoint/2015/main" val="1"/>
+              </p:ext>
+            </p:extLst>
+          </p:nvPr>
+        </p:nvSpPr>
+        <p:spPr>
+          <a:xfrm>
+            <a:off x="0" y="0"/>
+            <a:ext cx="12192000" cy="6858000"/>
+          </a:xfrm>
+          <a:prstGeom prst="rect">
+            <a:avLst/>
+          </a:prstGeom>
+          <a:ln/>
+        </p:spPr>
+        <p:style>
+          <a:lnRef idx="2">
+            <a:schemeClr val="accent2"/>
+          </a:lnRef>
+          <a:fillRef idx="1003">
+            <a:schemeClr val="dk1"/>
+          </a:fillRef>
+          <a:effectRef idx="0">
+            <a:schemeClr val="accent2"/>
+          </a:effectRef>
+          <a:fontRef idx="minor">
+            <a:schemeClr val="dk1"/>
+          </a:fontRef>
+        </p:style>
+        <p:txBody>
+          <a:bodyPr rtlCol="0" anchor="ctr"/>
+          <a:lstStyle/>
+          <a:p>
+            <a:pPr marL="0" marR="0" lvl="0" indent="0" algn="ctr" defTabSz="914400" rtl="0" eaLnBrk="1" fontAlgn="auto" latinLnBrk="0" hangingPunct="1">
+              <a:lnSpc>
+                <a:spcPct val="100000"/>
+              </a:lnSpc>
+              <a:spcBef>
+                <a:spcPts val="0"/>
+              </a:spcBef>
+              <a:spcAft>
+                <a:spcPts val="0"/>
+              </a:spcAft>
+              <a:buClrTx/>
+              <a:buSzTx/>
+              <a:buFontTx/>
+              <a:buNone/>
+              <a:tabLst/>
+              <a:defRPr/>
+            </a:pPr>
+            <a:endParaRPr kumimoji="0" lang="en-US" sz="1800" b="0" i="0" u="none" strike="noStrike" kern="0" cap="none" spc="0" normalizeH="0" baseline="0" noProof="0">
+              <a:ln>
+                <a:noFill/>
+              </a:ln>
+              <a:solidFill>
+                <a:prstClr val="white"/>
+              </a:solidFill>
+              <a:effectLst/>
+              <a:uLnTx/>
+              <a:uFillTx/>
+              <a:latin typeface="Garamond" panose="02020404030301010803"/>
+              <a:ea typeface="+mn-ea"/>
+              <a:cs typeface="+mn-cs"/>
+            </a:endParaRPr>
+          </a:p>
+        </p:txBody>
+      </p:sp>
+      <p:sp>
+        <p:nvSpPr>
+          <p:cNvPr id="10" name="Rectangle 9">
+            <a:extLst>
+              <a:ext uri="{FF2B5EF4-FFF2-40B4-BE49-F238E27FC236}">
+                <a16:creationId xmlns:a16="http://schemas.microsoft.com/office/drawing/2014/main" id="{B1D13D13-FAEE-4BC8-B0D0-9D476834B2C1}"/>
+              </a:ext>
+              <a:ext uri="{C183D7F6-B498-43B3-948B-1728B52AA6E4}">
+                <adec:decorative xmlns:adec="http://schemas.microsoft.com/office/drawing/2017/decorative" val="1"/>
+              </a:ext>
+            </a:extLst>
+          </p:cNvPr>
+          <p:cNvSpPr>
+            <a:spLocks noGrp="1" noRot="1" noChangeAspect="1" noMove="1" noResize="1" noEditPoints="1" noAdjustHandles="1" noChangeArrowheads="1" noChangeShapeType="1" noTextEdit="1"/>
+          </p:cNvSpPr>
+          <p:nvPr>
+            <p:extLst>
+              <p:ext uri="{386F3935-93C4-4BCD-93E2-E3B085C9AB24}">
+                <p16:designElem xmlns:p16="http://schemas.microsoft.com/office/powerpoint/2015/main" val="1"/>
+              </p:ext>
+            </p:extLst>
+          </p:nvPr>
+        </p:nvSpPr>
+        <p:spPr>
+          <a:xfrm>
+            <a:off x="-1" y="0"/>
+            <a:ext cx="12192000" cy="6858000"/>
+          </a:xfrm>
+          <a:prstGeom prst="rect">
+            <a:avLst/>
+          </a:prstGeom>
+          <a:solidFill>
+            <a:schemeClr val="tx1">
+              <a:alpha val="50000"/>
+            </a:schemeClr>
+          </a:solidFill>
+          <a:ln>
+            <a:noFill/>
+          </a:ln>
+        </p:spPr>
+        <p:style>
+          <a:lnRef idx="2">
+            <a:schemeClr val="accent1">
+              <a:shade val="50000"/>
+            </a:schemeClr>
+          </a:lnRef>
+          <a:fillRef idx="1">
+            <a:schemeClr val="accent1"/>
+          </a:fillRef>
+          <a:effectRef idx="0">
+            <a:schemeClr val="accent1"/>
+          </a:effectRef>
+          <a:fontRef idx="minor">
+            <a:schemeClr val="lt1"/>
+          </a:fontRef>
+        </p:style>
+        <p:txBody>
+          <a:bodyPr rtlCol="0" anchor="ctr"/>
+          <a:lstStyle/>
+          <a:p>
+            <a:pPr marL="0" marR="0" lvl="0" indent="0" algn="ctr" defTabSz="457200" rtl="0" eaLnBrk="1" fontAlgn="auto" latinLnBrk="0" hangingPunct="1">
+              <a:lnSpc>
+                <a:spcPct val="100000"/>
+              </a:lnSpc>
+              <a:spcBef>
+                <a:spcPts val="0"/>
+              </a:spcBef>
+              <a:spcAft>
+                <a:spcPts val="0"/>
+              </a:spcAft>
+              <a:buClrTx/>
+              <a:buSzTx/>
+              <a:buFontTx/>
+              <a:buNone/>
+              <a:tabLst/>
+              <a:defRPr/>
+            </a:pPr>
+            <a:endParaRPr kumimoji="0" lang="en-US" sz="1800" b="0" i="0" u="none" strike="noStrike" kern="1200" cap="none" spc="0" normalizeH="0" baseline="0" noProof="0">
+              <a:ln>
+                <a:noFill/>
+              </a:ln>
+              <a:solidFill>
+                <a:prstClr val="white"/>
+              </a:solidFill>
+              <a:effectLst/>
+              <a:uLnTx/>
+              <a:uFillTx/>
+              <a:latin typeface="Garamond" panose="02020404030301010803"/>
+              <a:ea typeface="+mn-ea"/>
+              <a:cs typeface="+mn-cs"/>
+            </a:endParaRPr>
+          </a:p>
+        </p:txBody>
+      </p:sp>
+      <p:sp>
+        <p:nvSpPr>
+          <p:cNvPr id="2" name="Title 1">
+            <a:extLst>
+              <a:ext uri="{FF2B5EF4-FFF2-40B4-BE49-F238E27FC236}">
+                <a16:creationId xmlns:a16="http://schemas.microsoft.com/office/drawing/2014/main" id="{DE7FA37B-95F1-4C56-A310-C85B64F55DF7}"/>
+              </a:ext>
+            </a:extLst>
+          </p:cNvPr>
+          <p:cNvSpPr>
+            <a:spLocks noGrp="1"/>
+          </p:cNvSpPr>
+          <p:nvPr>
+            <p:ph type="title"/>
+          </p:nvPr>
+        </p:nvSpPr>
+        <p:spPr>
+          <a:xfrm>
+            <a:off x="1295401" y="2607041"/>
+            <a:ext cx="9601196" cy="1303867"/>
+          </a:xfrm>
+        </p:spPr>
+        <p:txBody>
+          <a:bodyPr>
+            <a:normAutofit/>
+          </a:bodyPr>
+          <a:lstStyle/>
+          <a:p>
+            <a:r>
+              <a:rPr lang="en-US" b="1" dirty="0">
+                <a:solidFill>
+                  <a:schemeClr val="bg1"/>
+                </a:solidFill>
+              </a:rPr>
               <a:t>String Manipulation in C</a:t>
             </a:r>
           </a:p>
@@ -13538,110 +15411,7 @@
 </p:sld>
 </file>
 
-<file path=ppt/slides/slide3.xml><?xml version="1.0" encoding="utf-8"?>
-<p:sld xmlns:a="http://schemas.openxmlformats.org/drawingml/2006/main" xmlns:r="http://schemas.openxmlformats.org/officeDocument/2006/relationships" xmlns:p="http://schemas.openxmlformats.org/presentationml/2006/main">
-  <p:cSld>
-    <p:spTree>
-      <p:nvGrpSpPr>
-        <p:cNvPr id="1" name=""/>
-        <p:cNvGrpSpPr/>
-        <p:nvPr/>
-      </p:nvGrpSpPr>
-      <p:grpSpPr>
-        <a:xfrm>
-          <a:off x="0" y="0"/>
-          <a:ext cx="0" cy="0"/>
-          <a:chOff x="0" y="0"/>
-          <a:chExt cx="0" cy="0"/>
-        </a:xfrm>
-      </p:grpSpPr>
-      <p:sp>
-        <p:nvSpPr>
-          <p:cNvPr id="2" name="Title 1">
-            <a:extLst>
-              <a:ext uri="{FF2B5EF4-FFF2-40B4-BE49-F238E27FC236}">
-                <a16:creationId xmlns:a16="http://schemas.microsoft.com/office/drawing/2014/main" id="{8BB4D0F0-FBA2-49E3-817A-318F6577CF50}"/>
-              </a:ext>
-            </a:extLst>
-          </p:cNvPr>
-          <p:cNvSpPr>
-            <a:spLocks noGrp="1"/>
-          </p:cNvSpPr>
-          <p:nvPr>
-            <p:ph type="title"/>
-          </p:nvPr>
-        </p:nvSpPr>
-        <p:spPr/>
-        <p:txBody>
-          <a:bodyPr/>
-          <a:lstStyle/>
-          <a:p>
-            <a:r>
-              <a:rPr lang="en-US" dirty="0"/>
-              <a:t>Lab 2 will be out soon!</a:t>
-            </a:r>
-          </a:p>
-        </p:txBody>
-      </p:sp>
-      <p:sp>
-        <p:nvSpPr>
-          <p:cNvPr id="3" name="Content Placeholder 2">
-            <a:extLst>
-              <a:ext uri="{FF2B5EF4-FFF2-40B4-BE49-F238E27FC236}">
-                <a16:creationId xmlns:a16="http://schemas.microsoft.com/office/drawing/2014/main" id="{AE95FED5-3241-4328-A4BC-4DEF0FD5ACBA}"/>
-              </a:ext>
-            </a:extLst>
-          </p:cNvPr>
-          <p:cNvSpPr>
-            <a:spLocks noGrp="1"/>
-          </p:cNvSpPr>
-          <p:nvPr>
-            <p:ph idx="1"/>
-          </p:nvPr>
-        </p:nvSpPr>
-        <p:spPr/>
-        <p:txBody>
-          <a:bodyPr/>
-          <a:lstStyle/>
-          <a:p>
-            <a:r>
-              <a:rPr lang="en-US" dirty="0"/>
-              <a:t>The focus on Lab 2 will be </a:t>
-            </a:r>
-            <a:r>
-              <a:rPr lang="en-US" b="1" dirty="0"/>
-              <a:t>pointer arithmetic</a:t>
-            </a:r>
-            <a:endParaRPr lang="en-US" dirty="0"/>
-          </a:p>
-          <a:p>
-            <a:r>
-              <a:rPr lang="en-US" dirty="0"/>
-              <a:t>So, I’ll be talking about pointers!</a:t>
-            </a:r>
-          </a:p>
-          <a:p>
-            <a:pPr marL="0" indent="0">
-              <a:buNone/>
-            </a:pPr>
-            <a:endParaRPr lang="en-US" dirty="0"/>
-          </a:p>
-        </p:txBody>
-      </p:sp>
-    </p:spTree>
-    <p:extLst>
-      <p:ext uri="{BB962C8B-B14F-4D97-AF65-F5344CB8AC3E}">
-        <p14:creationId xmlns:p14="http://schemas.microsoft.com/office/powerpoint/2010/main" val="1155764117"/>
-      </p:ext>
-    </p:extLst>
-  </p:cSld>
-  <p:clrMapOvr>
-    <a:masterClrMapping/>
-  </p:clrMapOvr>
-</p:sld>
-</file>
-
-<file path=ppt/slides/slide30.xml><?xml version="1.0" encoding="utf-8"?>
+<file path=ppt/slides/slide33.xml><?xml version="1.0" encoding="utf-8"?>
 <p:sld xmlns:a="http://schemas.openxmlformats.org/drawingml/2006/main" xmlns:r="http://schemas.openxmlformats.org/officeDocument/2006/relationships" xmlns:p="http://schemas.openxmlformats.org/presentationml/2006/main">
   <p:cSld>
     <p:spTree>
@@ -14108,7 +15878,7 @@
 </p:sld>
 </file>
 
-<file path=ppt/slides/slide31.xml><?xml version="1.0" encoding="utf-8"?>
+<file path=ppt/slides/slide34.xml><?xml version="1.0" encoding="utf-8"?>
 <p:sld xmlns:a="http://schemas.openxmlformats.org/drawingml/2006/main" xmlns:r="http://schemas.openxmlformats.org/officeDocument/2006/relationships" xmlns:p="http://schemas.openxmlformats.org/presentationml/2006/main">
   <p:cSld>
     <p:spTree>
@@ -14249,6 +16019,109 @@
 </file>
 
 <file path=ppt/slides/slide4.xml><?xml version="1.0" encoding="utf-8"?>
+<p:sld xmlns:a="http://schemas.openxmlformats.org/drawingml/2006/main" xmlns:r="http://schemas.openxmlformats.org/officeDocument/2006/relationships" xmlns:p="http://schemas.openxmlformats.org/presentationml/2006/main">
+  <p:cSld>
+    <p:spTree>
+      <p:nvGrpSpPr>
+        <p:cNvPr id="1" name=""/>
+        <p:cNvGrpSpPr/>
+        <p:nvPr/>
+      </p:nvGrpSpPr>
+      <p:grpSpPr>
+        <a:xfrm>
+          <a:off x="0" y="0"/>
+          <a:ext cx="0" cy="0"/>
+          <a:chOff x="0" y="0"/>
+          <a:chExt cx="0" cy="0"/>
+        </a:xfrm>
+      </p:grpSpPr>
+      <p:sp>
+        <p:nvSpPr>
+          <p:cNvPr id="2" name="Title 1">
+            <a:extLst>
+              <a:ext uri="{FF2B5EF4-FFF2-40B4-BE49-F238E27FC236}">
+                <a16:creationId xmlns:a16="http://schemas.microsoft.com/office/drawing/2014/main" id="{8BB4D0F0-FBA2-49E3-817A-318F6577CF50}"/>
+              </a:ext>
+            </a:extLst>
+          </p:cNvPr>
+          <p:cNvSpPr>
+            <a:spLocks noGrp="1"/>
+          </p:cNvSpPr>
+          <p:nvPr>
+            <p:ph type="title"/>
+          </p:nvPr>
+        </p:nvSpPr>
+        <p:spPr/>
+        <p:txBody>
+          <a:bodyPr/>
+          <a:lstStyle/>
+          <a:p>
+            <a:r>
+              <a:rPr lang="en-US" dirty="0"/>
+              <a:t>Lab 2 will be out on Monday (probably)!</a:t>
+            </a:r>
+          </a:p>
+        </p:txBody>
+      </p:sp>
+      <p:sp>
+        <p:nvSpPr>
+          <p:cNvPr id="3" name="Content Placeholder 2">
+            <a:extLst>
+              <a:ext uri="{FF2B5EF4-FFF2-40B4-BE49-F238E27FC236}">
+                <a16:creationId xmlns:a16="http://schemas.microsoft.com/office/drawing/2014/main" id="{AE95FED5-3241-4328-A4BC-4DEF0FD5ACBA}"/>
+              </a:ext>
+            </a:extLst>
+          </p:cNvPr>
+          <p:cNvSpPr>
+            <a:spLocks noGrp="1"/>
+          </p:cNvSpPr>
+          <p:nvPr>
+            <p:ph idx="1"/>
+          </p:nvPr>
+        </p:nvSpPr>
+        <p:spPr/>
+        <p:txBody>
+          <a:bodyPr/>
+          <a:lstStyle/>
+          <a:p>
+            <a:r>
+              <a:rPr lang="en-US" dirty="0"/>
+              <a:t>The focus on Lab 2 will be </a:t>
+            </a:r>
+            <a:r>
+              <a:rPr lang="en-US" b="1" dirty="0"/>
+              <a:t>pointer arithmetic</a:t>
+            </a:r>
+            <a:endParaRPr lang="en-US" dirty="0"/>
+          </a:p>
+          <a:p>
+            <a:r>
+              <a:rPr lang="en-US" dirty="0"/>
+              <a:t>So, I’ll be talking about pointers!</a:t>
+            </a:r>
+          </a:p>
+          <a:p>
+            <a:pPr marL="0" indent="0">
+              <a:buNone/>
+            </a:pPr>
+            <a:endParaRPr lang="en-US" dirty="0"/>
+          </a:p>
+        </p:txBody>
+      </p:sp>
+    </p:spTree>
+    <p:extLst>
+      <p:ext uri="{BB962C8B-B14F-4D97-AF65-F5344CB8AC3E}">
+        <p14:creationId xmlns:p14="http://schemas.microsoft.com/office/powerpoint/2010/main" val="1155764117"/>
+      </p:ext>
+    </p:extLst>
+  </p:cSld>
+  <p:clrMapOvr>
+    <a:masterClrMapping/>
+  </p:clrMapOvr>
+</p:sld>
+</file>
+
+<file path=ppt/slides/slide5.xml><?xml version="1.0" encoding="utf-8"?>
 <p:sld xmlns:a="http://schemas.openxmlformats.org/drawingml/2006/main" xmlns:r="http://schemas.openxmlformats.org/officeDocument/2006/relationships" xmlns:p="http://schemas.openxmlformats.org/presentationml/2006/main">
   <p:cSld>
     <p:bg>
@@ -14522,7 +16395,7 @@
 </p:sld>
 </file>
 
-<file path=ppt/slides/slide5.xml><?xml version="1.0" encoding="utf-8"?>
+<file path=ppt/slides/slide6.xml><?xml version="1.0" encoding="utf-8"?>
 <p:sld xmlns:a="http://schemas.openxmlformats.org/drawingml/2006/main" xmlns:r="http://schemas.openxmlformats.org/officeDocument/2006/relationships" xmlns:p="http://schemas.openxmlformats.org/presentationml/2006/main">
   <p:cSld>
     <p:spTree>
@@ -15088,7 +16961,7 @@
 </p:sld>
 </file>
 
-<file path=ppt/slides/slide6.xml><?xml version="1.0" encoding="utf-8"?>
+<file path=ppt/slides/slide7.xml><?xml version="1.0" encoding="utf-8"?>
 <p:sld xmlns:a="http://schemas.openxmlformats.org/drawingml/2006/main" xmlns:r="http://schemas.openxmlformats.org/officeDocument/2006/relationships" xmlns:p="http://schemas.openxmlformats.org/presentationml/2006/main">
   <p:cSld>
     <p:spTree>
@@ -15703,7 +17576,7 @@
 </p:sld>
 </file>
 
-<file path=ppt/slides/slide7.xml><?xml version="1.0" encoding="utf-8"?>
+<file path=ppt/slides/slide8.xml><?xml version="1.0" encoding="utf-8"?>
 <p:sld xmlns:a="http://schemas.openxmlformats.org/drawingml/2006/main" xmlns:r="http://schemas.openxmlformats.org/officeDocument/2006/relationships" xmlns:p="http://schemas.openxmlformats.org/presentationml/2006/main">
   <p:cSld>
     <p:bg>
@@ -16006,7 +17879,7 @@
 </p:sld>
 </file>
 
-<file path=ppt/slides/slide8.xml><?xml version="1.0" encoding="utf-8"?>
+<file path=ppt/slides/slide9.xml><?xml version="1.0" encoding="utf-8"?>
 <p:sld xmlns:a="http://schemas.openxmlformats.org/drawingml/2006/main" xmlns:r="http://schemas.openxmlformats.org/officeDocument/2006/relationships" xmlns:p="http://schemas.openxmlformats.org/presentationml/2006/main">
   <p:cSld>
     <p:spTree>
@@ -16754,936 +18627,6 @@
 </p:sld>
 </file>
 
-<file path=ppt/slides/slide9.xml><?xml version="1.0" encoding="utf-8"?>
-<p:sld xmlns:a="http://schemas.openxmlformats.org/drawingml/2006/main" xmlns:r="http://schemas.openxmlformats.org/officeDocument/2006/relationships" xmlns:p="http://schemas.openxmlformats.org/presentationml/2006/main">
-  <p:cSld>
-    <p:spTree>
-      <p:nvGrpSpPr>
-        <p:cNvPr id="1" name=""/>
-        <p:cNvGrpSpPr/>
-        <p:nvPr/>
-      </p:nvGrpSpPr>
-      <p:grpSpPr>
-        <a:xfrm>
-          <a:off x="0" y="0"/>
-          <a:ext cx="0" cy="0"/>
-          <a:chOff x="0" y="0"/>
-          <a:chExt cx="0" cy="0"/>
-        </a:xfrm>
-      </p:grpSpPr>
-      <p:sp>
-        <p:nvSpPr>
-          <p:cNvPr id="2" name="Title 1">
-            <a:extLst>
-              <a:ext uri="{FF2B5EF4-FFF2-40B4-BE49-F238E27FC236}">
-                <a16:creationId xmlns:a16="http://schemas.microsoft.com/office/drawing/2014/main" id="{3CCD6262-0FD5-4436-9430-E0EB6B21C749}"/>
-              </a:ext>
-            </a:extLst>
-          </p:cNvPr>
-          <p:cNvSpPr>
-            <a:spLocks noGrp="1"/>
-          </p:cNvSpPr>
-          <p:nvPr>
-            <p:ph type="title"/>
-          </p:nvPr>
-        </p:nvSpPr>
-        <p:spPr/>
-        <p:txBody>
-          <a:bodyPr/>
-          <a:lstStyle/>
-          <a:p>
-            <a:r>
-              <a:rPr lang="en-US" dirty="0"/>
-              <a:t>Like a Locker Room!</a:t>
-            </a:r>
-          </a:p>
-        </p:txBody>
-      </p:sp>
-      <p:sp>
-        <p:nvSpPr>
-          <p:cNvPr id="3" name="Content Placeholder 2">
-            <a:extLst>
-              <a:ext uri="{FF2B5EF4-FFF2-40B4-BE49-F238E27FC236}">
-                <a16:creationId xmlns:a16="http://schemas.microsoft.com/office/drawing/2014/main" id="{8483FFE6-517E-4841-B36F-C053D682DDF1}"/>
-              </a:ext>
-            </a:extLst>
-          </p:cNvPr>
-          <p:cNvSpPr>
-            <a:spLocks noGrp="1"/>
-          </p:cNvSpPr>
-          <p:nvPr>
-            <p:ph idx="1"/>
-          </p:nvPr>
-        </p:nvSpPr>
-        <p:spPr/>
-        <p:txBody>
-          <a:bodyPr>
-            <a:normAutofit fontScale="55000" lnSpcReduction="20000"/>
-          </a:bodyPr>
-          <a:lstStyle/>
-          <a:p>
-            <a:pPr marL="0" indent="0">
-              <a:buNone/>
-            </a:pPr>
-            <a:r>
-              <a:rPr lang="en-US" dirty="0"/>
-              <a:t>1) Just like a locker </a:t>
-            </a:r>
-            <a:r>
-              <a:rPr lang="en-US" b="1" dirty="0"/>
-              <a:t>contains </a:t>
-            </a:r>
-            <a:r>
-              <a:rPr lang="en-US" b="1" i="1" dirty="0"/>
-              <a:t>things</a:t>
-            </a:r>
-            <a:r>
-              <a:rPr lang="en-US" dirty="0"/>
-              <a:t>…</a:t>
-            </a:r>
-          </a:p>
-          <a:p>
-            <a:pPr marL="0" indent="0">
-              <a:buNone/>
-            </a:pPr>
-            <a:r>
-              <a:rPr lang="en-US" dirty="0"/>
-              <a:t>- Variables contain </a:t>
-            </a:r>
-            <a:r>
-              <a:rPr lang="en-US" b="1" dirty="0"/>
-              <a:t>values</a:t>
-            </a:r>
-            <a:endParaRPr lang="en-US" dirty="0"/>
-          </a:p>
-          <a:p>
-            <a:pPr marL="0" indent="0">
-              <a:buNone/>
-            </a:pPr>
-            <a:r>
-              <a:rPr lang="en-US" dirty="0"/>
-              <a:t>- But a variable </a:t>
-            </a:r>
-            <a:r>
-              <a:rPr lang="en-US" i="1" dirty="0"/>
-              <a:t>is a </a:t>
-            </a:r>
-            <a:r>
-              <a:rPr lang="en-US" b="1" i="1" dirty="0"/>
-              <a:t>thing itself</a:t>
-            </a:r>
-            <a:endParaRPr lang="en-US" dirty="0"/>
-          </a:p>
-          <a:p>
-            <a:pPr marL="0" indent="0">
-              <a:buNone/>
-            </a:pPr>
-            <a:r>
-              <a:rPr lang="en-US" dirty="0"/>
-              <a:t>2) Each variable is like a locker:</a:t>
-            </a:r>
-          </a:p>
-          <a:p>
-            <a:pPr marL="0" indent="0">
-              <a:buNone/>
-            </a:pPr>
-            <a:r>
-              <a:rPr lang="en-US" dirty="0"/>
-              <a:t>- It has a </a:t>
-            </a:r>
-            <a:r>
-              <a:rPr lang="en-US" b="1" dirty="0"/>
-              <a:t>number: </a:t>
-            </a:r>
-            <a:r>
-              <a:rPr lang="en-US" dirty="0"/>
-              <a:t>its </a:t>
-            </a:r>
-            <a:r>
-              <a:rPr lang="en-US" b="1" dirty="0"/>
-              <a:t>address</a:t>
-            </a:r>
-            <a:endParaRPr lang="en-US" dirty="0"/>
-          </a:p>
-          <a:p>
-            <a:pPr marL="0" indent="0">
-              <a:buNone/>
-            </a:pPr>
-            <a:r>
-              <a:rPr lang="en-US" dirty="0"/>
-              <a:t>- It </a:t>
-            </a:r>
-            <a:r>
-              <a:rPr lang="en-US" b="1" dirty="0"/>
-              <a:t>contains </a:t>
-            </a:r>
-            <a:r>
-              <a:rPr lang="en-US" dirty="0"/>
-              <a:t>something: its </a:t>
-            </a:r>
-            <a:r>
-              <a:rPr lang="en-US" b="1" dirty="0"/>
-              <a:t>value</a:t>
-            </a:r>
-            <a:endParaRPr lang="en-US" dirty="0"/>
-          </a:p>
-          <a:p>
-            <a:pPr marL="0" indent="0">
-              <a:buNone/>
-            </a:pPr>
-            <a:r>
-              <a:rPr lang="en-US" dirty="0"/>
-              <a:t>- It </a:t>
-            </a:r>
-            <a:r>
-              <a:rPr lang="en-US" b="1" dirty="0"/>
-              <a:t>belongs</a:t>
-            </a:r>
-            <a:r>
-              <a:rPr lang="en-US" dirty="0"/>
-              <a:t> to someone: its </a:t>
-            </a:r>
-            <a:r>
-              <a:rPr lang="en-US" b="1" dirty="0"/>
-              <a:t>owner</a:t>
-            </a:r>
-            <a:endParaRPr lang="en-US" dirty="0"/>
-          </a:p>
-          <a:p>
-            <a:pPr marL="0" indent="0">
-              <a:buNone/>
-            </a:pPr>
-            <a:r>
-              <a:rPr lang="en-US" dirty="0"/>
-              <a:t>3) How do you </a:t>
-            </a:r>
-            <a:r>
-              <a:rPr lang="en-US" i="1" dirty="0"/>
-              <a:t>give </a:t>
-            </a:r>
-            <a:r>
-              <a:rPr lang="en-US" b="1" i="1" dirty="0"/>
-              <a:t>someone else access</a:t>
-            </a:r>
-            <a:r>
-              <a:rPr lang="en-US" i="1" dirty="0"/>
-              <a:t> </a:t>
-            </a:r>
-            <a:r>
-              <a:rPr lang="en-US" dirty="0"/>
-              <a:t>to your variable?</a:t>
-            </a:r>
-          </a:p>
-          <a:p>
-            <a:pPr marL="0" indent="0">
-              <a:buNone/>
-            </a:pPr>
-            <a:r>
-              <a:rPr lang="en-US" dirty="0"/>
-              <a:t>- </a:t>
-            </a:r>
-            <a:r>
-              <a:rPr lang="en-US" b="1" i="1" dirty="0"/>
-              <a:t>You give them the locker number</a:t>
-            </a:r>
-            <a:r>
-              <a:rPr lang="en-US" i="1" dirty="0"/>
-              <a:t>.</a:t>
-            </a:r>
-            <a:endParaRPr lang="en-US" dirty="0"/>
-          </a:p>
-          <a:p>
-            <a:pPr marL="0" lvl="0" indent="0">
-              <a:buNone/>
-            </a:pPr>
-            <a:r>
-              <a:rPr lang="en-US" dirty="0"/>
-              <a:t>- Which is its </a:t>
-            </a:r>
-            <a:r>
-              <a:rPr lang="en-US" b="1" dirty="0"/>
-              <a:t>memory address.</a:t>
-            </a:r>
-            <a:endParaRPr lang="en-US" dirty="0"/>
-          </a:p>
-          <a:p>
-            <a:pPr marL="0" indent="0">
-              <a:buNone/>
-            </a:pPr>
-            <a:r>
-              <a:rPr lang="en-US" dirty="0"/>
-              <a:t>- Variable names are just a convenient way to refer to their addresses!</a:t>
-            </a:r>
-          </a:p>
-          <a:p>
-            <a:endParaRPr lang="en-US" dirty="0"/>
-          </a:p>
-        </p:txBody>
-      </p:sp>
-      <p:pic>
-        <p:nvPicPr>
-          <p:cNvPr id="4" name="Picture 3">
-            <a:extLst>
-              <a:ext uri="{FF2B5EF4-FFF2-40B4-BE49-F238E27FC236}">
-                <a16:creationId xmlns:a16="http://schemas.microsoft.com/office/drawing/2014/main" id="{005528FB-2413-41DC-91E4-F58E9FCA38D8}"/>
-              </a:ext>
-            </a:extLst>
-          </p:cNvPr>
-          <p:cNvPicPr/>
-          <p:nvPr/>
-        </p:nvPicPr>
-        <p:blipFill>
-          <a:blip r:embed="rId2">
-            <a:extLst>
-              <a:ext uri="{28A0092B-C50C-407E-A947-70E740481C1C}">
-                <a14:useLocalDpi xmlns:a14="http://schemas.microsoft.com/office/drawing/2010/main" val="0"/>
-              </a:ext>
-            </a:extLst>
-          </a:blip>
-          <a:stretch>
-            <a:fillRect/>
-          </a:stretch>
-        </p:blipFill>
-        <p:spPr>
-          <a:xfrm>
-            <a:off x="5869952" y="2556932"/>
-            <a:ext cx="4893762" cy="3021504"/>
-          </a:xfrm>
-          <a:prstGeom prst="rect">
-            <a:avLst/>
-          </a:prstGeom>
-        </p:spPr>
-      </p:pic>
-    </p:spTree>
-    <p:extLst>
-      <p:ext uri="{BB962C8B-B14F-4D97-AF65-F5344CB8AC3E}">
-        <p14:creationId xmlns:p14="http://schemas.microsoft.com/office/powerpoint/2010/main" val="1700655484"/>
-      </p:ext>
-    </p:extLst>
-  </p:cSld>
-  <p:clrMapOvr>
-    <a:masterClrMapping/>
-  </p:clrMapOvr>
-  <p:timing>
-    <p:tnLst>
-      <p:par>
-        <p:cTn id="1" dur="indefinite" restart="never" nodeType="tmRoot">
-          <p:childTnLst>
-            <p:seq concurrent="1" nextAc="seek">
-              <p:cTn id="2" dur="indefinite" nodeType="mainSeq">
-                <p:childTnLst>
-                  <p:par>
-                    <p:cTn id="3" fill="hold">
-                      <p:stCondLst>
-                        <p:cond delay="indefinite"/>
-                      </p:stCondLst>
-                      <p:childTnLst>
-                        <p:par>
-                          <p:cTn id="4" fill="hold">
-                            <p:stCondLst>
-                              <p:cond delay="0"/>
-                            </p:stCondLst>
-                            <p:childTnLst>
-                              <p:par>
-                                <p:cTn id="5" presetID="1" presetClass="entr" presetSubtype="0" fill="hold" grpId="0" nodeType="clickEffect">
-                                  <p:stCondLst>
-                                    <p:cond delay="0"/>
-                                  </p:stCondLst>
-                                  <p:childTnLst>
-                                    <p:set>
-                                      <p:cBhvr>
-                                        <p:cTn id="6" dur="1" fill="hold">
-                                          <p:stCondLst>
-                                            <p:cond delay="0"/>
-                                          </p:stCondLst>
-                                        </p:cTn>
-                                        <p:tgtEl>
-                                          <p:spTgt spid="3">
-                                            <p:txEl>
-                                              <p:pRg st="0" end="0"/>
-                                            </p:txEl>
-                                          </p:spTgt>
-                                        </p:tgtEl>
-                                        <p:attrNameLst>
-                                          <p:attrName>style.visibility</p:attrName>
-                                        </p:attrNameLst>
-                                      </p:cBhvr>
-                                      <p:to>
-                                        <p:strVal val="visible"/>
-                                      </p:to>
-                                    </p:set>
-                                  </p:childTnLst>
-                                </p:cTn>
-                              </p:par>
-                            </p:childTnLst>
-                          </p:cTn>
-                        </p:par>
-                      </p:childTnLst>
-                    </p:cTn>
-                  </p:par>
-                  <p:par>
-                    <p:cTn id="7" fill="hold">
-                      <p:stCondLst>
-                        <p:cond delay="indefinite"/>
-                      </p:stCondLst>
-                      <p:childTnLst>
-                        <p:par>
-                          <p:cTn id="8" fill="hold">
-                            <p:stCondLst>
-                              <p:cond delay="0"/>
-                            </p:stCondLst>
-                            <p:childTnLst>
-                              <p:par>
-                                <p:cTn id="9" presetID="1" presetClass="entr" presetSubtype="0" fill="hold" grpId="0" nodeType="clickEffect">
-                                  <p:stCondLst>
-                                    <p:cond delay="0"/>
-                                  </p:stCondLst>
-                                  <p:childTnLst>
-                                    <p:set>
-                                      <p:cBhvr>
-                                        <p:cTn id="10" dur="1" fill="hold">
-                                          <p:stCondLst>
-                                            <p:cond delay="0"/>
-                                          </p:stCondLst>
-                                        </p:cTn>
-                                        <p:tgtEl>
-                                          <p:spTgt spid="3">
-                                            <p:txEl>
-                                              <p:pRg st="1" end="1"/>
-                                            </p:txEl>
-                                          </p:spTgt>
-                                        </p:tgtEl>
-                                        <p:attrNameLst>
-                                          <p:attrName>style.visibility</p:attrName>
-                                        </p:attrNameLst>
-                                      </p:cBhvr>
-                                      <p:to>
-                                        <p:strVal val="visible"/>
-                                      </p:to>
-                                    </p:set>
-                                  </p:childTnLst>
-                                </p:cTn>
-                              </p:par>
-                            </p:childTnLst>
-                          </p:cTn>
-                        </p:par>
-                      </p:childTnLst>
-                    </p:cTn>
-                  </p:par>
-                  <p:par>
-                    <p:cTn id="11" fill="hold">
-                      <p:stCondLst>
-                        <p:cond delay="indefinite"/>
-                      </p:stCondLst>
-                      <p:childTnLst>
-                        <p:par>
-                          <p:cTn id="12" fill="hold">
-                            <p:stCondLst>
-                              <p:cond delay="0"/>
-                            </p:stCondLst>
-                            <p:childTnLst>
-                              <p:par>
-                                <p:cTn id="13" presetID="1" presetClass="entr" presetSubtype="0" fill="hold" grpId="0" nodeType="clickEffect">
-                                  <p:stCondLst>
-                                    <p:cond delay="0"/>
-                                  </p:stCondLst>
-                                  <p:childTnLst>
-                                    <p:set>
-                                      <p:cBhvr>
-                                        <p:cTn id="14" dur="1" fill="hold">
-                                          <p:stCondLst>
-                                            <p:cond delay="0"/>
-                                          </p:stCondLst>
-                                        </p:cTn>
-                                        <p:tgtEl>
-                                          <p:spTgt spid="3">
-                                            <p:txEl>
-                                              <p:pRg st="2" end="2"/>
-                                            </p:txEl>
-                                          </p:spTgt>
-                                        </p:tgtEl>
-                                        <p:attrNameLst>
-                                          <p:attrName>style.visibility</p:attrName>
-                                        </p:attrNameLst>
-                                      </p:cBhvr>
-                                      <p:to>
-                                        <p:strVal val="visible"/>
-                                      </p:to>
-                                    </p:set>
-                                  </p:childTnLst>
-                                </p:cTn>
-                              </p:par>
-                            </p:childTnLst>
-                          </p:cTn>
-                        </p:par>
-                      </p:childTnLst>
-                    </p:cTn>
-                  </p:par>
-                  <p:par>
-                    <p:cTn id="15" fill="hold">
-                      <p:stCondLst>
-                        <p:cond delay="indefinite"/>
-                      </p:stCondLst>
-                      <p:childTnLst>
-                        <p:par>
-                          <p:cTn id="16" fill="hold">
-                            <p:stCondLst>
-                              <p:cond delay="0"/>
-                            </p:stCondLst>
-                            <p:childTnLst>
-                              <p:par>
-                                <p:cTn id="17" presetID="1" presetClass="entr" presetSubtype="0" fill="hold" grpId="0" nodeType="clickEffect">
-                                  <p:stCondLst>
-                                    <p:cond delay="0"/>
-                                  </p:stCondLst>
-                                  <p:childTnLst>
-                                    <p:set>
-                                      <p:cBhvr>
-                                        <p:cTn id="18" dur="1" fill="hold">
-                                          <p:stCondLst>
-                                            <p:cond delay="0"/>
-                                          </p:stCondLst>
-                                        </p:cTn>
-                                        <p:tgtEl>
-                                          <p:spTgt spid="3">
-                                            <p:txEl>
-                                              <p:pRg st="3" end="3"/>
-                                            </p:txEl>
-                                          </p:spTgt>
-                                        </p:tgtEl>
-                                        <p:attrNameLst>
-                                          <p:attrName>style.visibility</p:attrName>
-                                        </p:attrNameLst>
-                                      </p:cBhvr>
-                                      <p:to>
-                                        <p:strVal val="visible"/>
-                                      </p:to>
-                                    </p:set>
-                                  </p:childTnLst>
-                                </p:cTn>
-                              </p:par>
-                            </p:childTnLst>
-                          </p:cTn>
-                        </p:par>
-                      </p:childTnLst>
-                    </p:cTn>
-                  </p:par>
-                  <p:par>
-                    <p:cTn id="19" fill="hold">
-                      <p:stCondLst>
-                        <p:cond delay="indefinite"/>
-                      </p:stCondLst>
-                      <p:childTnLst>
-                        <p:par>
-                          <p:cTn id="20" fill="hold">
-                            <p:stCondLst>
-                              <p:cond delay="0"/>
-                            </p:stCondLst>
-                            <p:childTnLst>
-                              <p:par>
-                                <p:cTn id="21" presetID="1" presetClass="entr" presetSubtype="0" fill="hold" grpId="0" nodeType="clickEffect">
-                                  <p:stCondLst>
-                                    <p:cond delay="0"/>
-                                  </p:stCondLst>
-                                  <p:childTnLst>
-                                    <p:set>
-                                      <p:cBhvr>
-                                        <p:cTn id="22" dur="1" fill="hold">
-                                          <p:stCondLst>
-                                            <p:cond delay="0"/>
-                                          </p:stCondLst>
-                                        </p:cTn>
-                                        <p:tgtEl>
-                                          <p:spTgt spid="3">
-                                            <p:txEl>
-                                              <p:pRg st="4" end="4"/>
-                                            </p:txEl>
-                                          </p:spTgt>
-                                        </p:tgtEl>
-                                        <p:attrNameLst>
-                                          <p:attrName>style.visibility</p:attrName>
-                                        </p:attrNameLst>
-                                      </p:cBhvr>
-                                      <p:to>
-                                        <p:strVal val="visible"/>
-                                      </p:to>
-                                    </p:set>
-                                  </p:childTnLst>
-                                </p:cTn>
-                              </p:par>
-                            </p:childTnLst>
-                          </p:cTn>
-                        </p:par>
-                      </p:childTnLst>
-                    </p:cTn>
-                  </p:par>
-                  <p:par>
-                    <p:cTn id="23" fill="hold">
-                      <p:stCondLst>
-                        <p:cond delay="indefinite"/>
-                      </p:stCondLst>
-                      <p:childTnLst>
-                        <p:par>
-                          <p:cTn id="24" fill="hold">
-                            <p:stCondLst>
-                              <p:cond delay="0"/>
-                            </p:stCondLst>
-                            <p:childTnLst>
-                              <p:par>
-                                <p:cTn id="25" presetID="1" presetClass="entr" presetSubtype="0" fill="hold" grpId="0" nodeType="clickEffect">
-                                  <p:stCondLst>
-                                    <p:cond delay="0"/>
-                                  </p:stCondLst>
-                                  <p:childTnLst>
-                                    <p:set>
-                                      <p:cBhvr>
-                                        <p:cTn id="26" dur="1" fill="hold">
-                                          <p:stCondLst>
-                                            <p:cond delay="0"/>
-                                          </p:stCondLst>
-                                        </p:cTn>
-                                        <p:tgtEl>
-                                          <p:spTgt spid="3">
-                                            <p:txEl>
-                                              <p:pRg st="5" end="5"/>
-                                            </p:txEl>
-                                          </p:spTgt>
-                                        </p:tgtEl>
-                                        <p:attrNameLst>
-                                          <p:attrName>style.visibility</p:attrName>
-                                        </p:attrNameLst>
-                                      </p:cBhvr>
-                                      <p:to>
-                                        <p:strVal val="visible"/>
-                                      </p:to>
-                                    </p:set>
-                                  </p:childTnLst>
-                                </p:cTn>
-                              </p:par>
-                            </p:childTnLst>
-                          </p:cTn>
-                        </p:par>
-                      </p:childTnLst>
-                    </p:cTn>
-                  </p:par>
-                  <p:par>
-                    <p:cTn id="27" fill="hold">
-                      <p:stCondLst>
-                        <p:cond delay="indefinite"/>
-                      </p:stCondLst>
-                      <p:childTnLst>
-                        <p:par>
-                          <p:cTn id="28" fill="hold">
-                            <p:stCondLst>
-                              <p:cond delay="0"/>
-                            </p:stCondLst>
-                            <p:childTnLst>
-                              <p:par>
-                                <p:cTn id="29" presetID="1" presetClass="entr" presetSubtype="0" fill="hold" grpId="0" nodeType="clickEffect">
-                                  <p:stCondLst>
-                                    <p:cond delay="0"/>
-                                  </p:stCondLst>
-                                  <p:childTnLst>
-                                    <p:set>
-                                      <p:cBhvr>
-                                        <p:cTn id="30" dur="1" fill="hold">
-                                          <p:stCondLst>
-                                            <p:cond delay="0"/>
-                                          </p:stCondLst>
-                                        </p:cTn>
-                                        <p:tgtEl>
-                                          <p:spTgt spid="3">
-                                            <p:txEl>
-                                              <p:pRg st="6" end="6"/>
-                                            </p:txEl>
-                                          </p:spTgt>
-                                        </p:tgtEl>
-                                        <p:attrNameLst>
-                                          <p:attrName>style.visibility</p:attrName>
-                                        </p:attrNameLst>
-                                      </p:cBhvr>
-                                      <p:to>
-                                        <p:strVal val="visible"/>
-                                      </p:to>
-                                    </p:set>
-                                  </p:childTnLst>
-                                </p:cTn>
-                              </p:par>
-                            </p:childTnLst>
-                          </p:cTn>
-                        </p:par>
-                      </p:childTnLst>
-                    </p:cTn>
-                  </p:par>
-                  <p:par>
-                    <p:cTn id="31" fill="hold">
-                      <p:stCondLst>
-                        <p:cond delay="indefinite"/>
-                      </p:stCondLst>
-                      <p:childTnLst>
-                        <p:par>
-                          <p:cTn id="32" fill="hold">
-                            <p:stCondLst>
-                              <p:cond delay="0"/>
-                            </p:stCondLst>
-                            <p:childTnLst>
-                              <p:par>
-                                <p:cTn id="33" presetID="1" presetClass="entr" presetSubtype="0" fill="hold" grpId="0" nodeType="clickEffect">
-                                  <p:stCondLst>
-                                    <p:cond delay="0"/>
-                                  </p:stCondLst>
-                                  <p:childTnLst>
-                                    <p:set>
-                                      <p:cBhvr>
-                                        <p:cTn id="34" dur="1" fill="hold">
-                                          <p:stCondLst>
-                                            <p:cond delay="0"/>
-                                          </p:stCondLst>
-                                        </p:cTn>
-                                        <p:tgtEl>
-                                          <p:spTgt spid="3">
-                                            <p:txEl>
-                                              <p:pRg st="7" end="7"/>
-                                            </p:txEl>
-                                          </p:spTgt>
-                                        </p:tgtEl>
-                                        <p:attrNameLst>
-                                          <p:attrName>style.visibility</p:attrName>
-                                        </p:attrNameLst>
-                                      </p:cBhvr>
-                                      <p:to>
-                                        <p:strVal val="visible"/>
-                                      </p:to>
-                                    </p:set>
-                                  </p:childTnLst>
-                                </p:cTn>
-                              </p:par>
-                            </p:childTnLst>
-                          </p:cTn>
-                        </p:par>
-                      </p:childTnLst>
-                    </p:cTn>
-                  </p:par>
-                  <p:par>
-                    <p:cTn id="35" fill="hold">
-                      <p:stCondLst>
-                        <p:cond delay="indefinite"/>
-                      </p:stCondLst>
-                      <p:childTnLst>
-                        <p:par>
-                          <p:cTn id="36" fill="hold">
-                            <p:stCondLst>
-                              <p:cond delay="0"/>
-                            </p:stCondLst>
-                            <p:childTnLst>
-                              <p:par>
-                                <p:cTn id="37" presetID="1" presetClass="entr" presetSubtype="0" fill="hold" grpId="0" nodeType="clickEffect">
-                                  <p:stCondLst>
-                                    <p:cond delay="0"/>
-                                  </p:stCondLst>
-                                  <p:childTnLst>
-                                    <p:set>
-                                      <p:cBhvr>
-                                        <p:cTn id="38" dur="1" fill="hold">
-                                          <p:stCondLst>
-                                            <p:cond delay="0"/>
-                                          </p:stCondLst>
-                                        </p:cTn>
-                                        <p:tgtEl>
-                                          <p:spTgt spid="3">
-                                            <p:txEl>
-                                              <p:pRg st="8" end="8"/>
-                                            </p:txEl>
-                                          </p:spTgt>
-                                        </p:tgtEl>
-                                        <p:attrNameLst>
-                                          <p:attrName>style.visibility</p:attrName>
-                                        </p:attrNameLst>
-                                      </p:cBhvr>
-                                      <p:to>
-                                        <p:strVal val="visible"/>
-                                      </p:to>
-                                    </p:set>
-                                  </p:childTnLst>
-                                </p:cTn>
-                              </p:par>
-                            </p:childTnLst>
-                          </p:cTn>
-                        </p:par>
-                      </p:childTnLst>
-                    </p:cTn>
-                  </p:par>
-                  <p:par>
-                    <p:cTn id="39" fill="hold">
-                      <p:stCondLst>
-                        <p:cond delay="indefinite"/>
-                      </p:stCondLst>
-                      <p:childTnLst>
-                        <p:par>
-                          <p:cTn id="40" fill="hold">
-                            <p:stCondLst>
-                              <p:cond delay="0"/>
-                            </p:stCondLst>
-                            <p:childTnLst>
-                              <p:par>
-                                <p:cTn id="41" presetID="1" presetClass="entr" presetSubtype="0" fill="hold" grpId="0" nodeType="clickEffect">
-                                  <p:stCondLst>
-                                    <p:cond delay="0"/>
-                                  </p:stCondLst>
-                                  <p:childTnLst>
-                                    <p:set>
-                                      <p:cBhvr>
-                                        <p:cTn id="42" dur="1" fill="hold">
-                                          <p:stCondLst>
-                                            <p:cond delay="0"/>
-                                          </p:stCondLst>
-                                        </p:cTn>
-                                        <p:tgtEl>
-                                          <p:spTgt spid="3">
-                                            <p:txEl>
-                                              <p:pRg st="9" end="9"/>
-                                            </p:txEl>
-                                          </p:spTgt>
-                                        </p:tgtEl>
-                                        <p:attrNameLst>
-                                          <p:attrName>style.visibility</p:attrName>
-                                        </p:attrNameLst>
-                                      </p:cBhvr>
-                                      <p:to>
-                                        <p:strVal val="visible"/>
-                                      </p:to>
-                                    </p:set>
-                                  </p:childTnLst>
-                                </p:cTn>
-                              </p:par>
-                            </p:childTnLst>
-                          </p:cTn>
-                        </p:par>
-                      </p:childTnLst>
-                    </p:cTn>
-                  </p:par>
-                  <p:par>
-                    <p:cTn id="43" fill="hold">
-                      <p:stCondLst>
-                        <p:cond delay="indefinite"/>
-                      </p:stCondLst>
-                      <p:childTnLst>
-                        <p:par>
-                          <p:cTn id="44" fill="hold">
-                            <p:stCondLst>
-                              <p:cond delay="0"/>
-                            </p:stCondLst>
-                            <p:childTnLst>
-                              <p:par>
-                                <p:cTn id="45" presetID="1" presetClass="entr" presetSubtype="0" fill="hold" grpId="0" nodeType="clickEffect">
-                                  <p:stCondLst>
-                                    <p:cond delay="0"/>
-                                  </p:stCondLst>
-                                  <p:childTnLst>
-                                    <p:set>
-                                      <p:cBhvr>
-                                        <p:cTn id="46" dur="1" fill="hold">
-                                          <p:stCondLst>
-                                            <p:cond delay="0"/>
-                                          </p:stCondLst>
-                                        </p:cTn>
-                                        <p:tgtEl>
-                                          <p:spTgt spid="3">
-                                            <p:txEl>
-                                              <p:pRg st="10" end="10"/>
-                                            </p:txEl>
-                                          </p:spTgt>
-                                        </p:tgtEl>
-                                        <p:attrNameLst>
-                                          <p:attrName>style.visibility</p:attrName>
-                                        </p:attrNameLst>
-                                      </p:cBhvr>
-                                      <p:to>
-                                        <p:strVal val="visible"/>
-                                      </p:to>
-                                    </p:set>
-                                  </p:childTnLst>
-                                </p:cTn>
-                              </p:par>
-                            </p:childTnLst>
-                          </p:cTn>
-                        </p:par>
-                      </p:childTnLst>
-                    </p:cTn>
-                  </p:par>
-                  <p:par>
-                    <p:cTn id="47" fill="hold">
-                      <p:stCondLst>
-                        <p:cond delay="indefinite"/>
-                      </p:stCondLst>
-                      <p:childTnLst>
-                        <p:par>
-                          <p:cTn id="48" fill="hold">
-                            <p:stCondLst>
-                              <p:cond delay="0"/>
-                            </p:stCondLst>
-                            <p:childTnLst>
-                              <p:par>
-                                <p:cTn id="49" presetID="1" presetClass="entr" presetSubtype="0" fill="hold" nodeType="clickEffect">
-                                  <p:stCondLst>
-                                    <p:cond delay="0"/>
-                                  </p:stCondLst>
-                                  <p:childTnLst>
-                                    <p:set>
-                                      <p:cBhvr>
-                                        <p:cTn id="50" dur="1" fill="hold">
-                                          <p:stCondLst>
-                                            <p:cond delay="0"/>
-                                          </p:stCondLst>
-                                        </p:cTn>
-                                        <p:tgtEl>
-                                          <p:spTgt spid="4"/>
-                                        </p:tgtEl>
-                                        <p:attrNameLst>
-                                          <p:attrName>style.visibility</p:attrName>
-                                        </p:attrNameLst>
-                                      </p:cBhvr>
-                                      <p:to>
-                                        <p:strVal val="visible"/>
-                                      </p:to>
-                                    </p:set>
-                                  </p:childTnLst>
-                                </p:cTn>
-                              </p:par>
-                            </p:childTnLst>
-                          </p:cTn>
-                        </p:par>
-                      </p:childTnLst>
-                    </p:cTn>
-                  </p:par>
-                </p:childTnLst>
-              </p:cTn>
-              <p:prevCondLst>
-                <p:cond evt="onPrev" delay="0">
-                  <p:tgtEl>
-                    <p:sldTgt/>
-                  </p:tgtEl>
-                </p:cond>
-              </p:prevCondLst>
-              <p:nextCondLst>
-                <p:cond evt="onNext" delay="0">
-                  <p:tgtEl>
-                    <p:sldTgt/>
-                  </p:tgtEl>
-                </p:cond>
-              </p:nextCondLst>
-            </p:seq>
-          </p:childTnLst>
-        </p:cTn>
-      </p:par>
-    </p:tnLst>
-    <p:bldLst>
-      <p:bldP spid="3" grpId="0" build="p"/>
-    </p:bldLst>
-  </p:timing>
-</p:sld>
-</file>
-
 <file path=ppt/theme/theme1.xml><?xml version="1.0" encoding="utf-8"?>
 <a:theme xmlns:a="http://schemas.openxmlformats.org/drawingml/2006/main" name="Organic">
   <a:themeElements>

</xml_diff>